<commit_message>
fix: aplica correcciones a los horarios, añade guia DOCX institucional y profundiza contenido de la Semana 1
</commit_message>
<xml_diff>
--- a/Semanas/Semana_1/diapositivas_semana_1.pptx
+++ b/Semanas/Semana_1/diapositivas_semana_1.pptx
@@ -12,6 +12,7 @@
     <p:sldId id="260" r:id="rId11"/>
     <p:sldId id="261" r:id="rId12"/>
     <p:sldId id="262" r:id="rId13"/>
+    <p:sldId id="263" r:id="rId14"/>
   </p:sldIdLst>
   <p:sldSz cx="12191695" cy="6858000" type="screen4x3"/>
   <p:notesSz cx="6858000" cy="9144000"/>
@@ -3322,7 +3323,7 @@
               </a:defRPr>
             </a:pPr>
             <a:r>
-              <a:t>Para un ambiente de aprendizaje seguro y productivo:</a:t>
+              <a:t>Horario Oficial: Viernes de 10:00 AM a 1:00 PM.</a:t>
             </a:r>
           </a:p>
           <a:p>
@@ -3335,7 +3336,7 @@
               </a:defRPr>
             </a:pPr>
             <a:r>
-              <a:t>Puntualidad: Iniciamos a las 7:00 AM en punto.</a:t>
+              <a:t>Puntualidad: Llegar a tiempo garantiza no perder conceptos clave.</a:t>
             </a:r>
           </a:p>
           <a:p>
@@ -3348,7 +3349,7 @@
               </a:defRPr>
             </a:pPr>
             <a:r>
-              <a:t>Descansos Cognitivos: Haremos una pausa para evitar fatiga.</a:t>
+              <a:t>Descansos Cognitivos: Haremos una pausa a las 11:30 AM.</a:t>
             </a:r>
           </a:p>
           <a:p>
@@ -3361,20 +3362,7 @@
               </a:defRPr>
             </a:pPr>
             <a:r>
-              <a:t>Estrategia EMI: Inmersiones cortas en inglés para fortalecer vocabulario.</a:t>
-            </a:r>
-          </a:p>
-          <a:p>
-            <a:pPr lvl="1">
-              <a:defRPr sz="2400" b="0">
-                <a:solidFill>
-                  <a:srgbClr val="003865"/>
-                </a:solidFill>
-                <a:latin typeface="Century Gothic"/>
-              </a:defRPr>
-            </a:pPr>
-            <a:r>
-              <a:t>Uso de IA: Usaremos LLMNotebook como copiloto ético.</a:t>
+              <a:t>Estrategia EMI: 10 minutos de inmersión en inglés por sesión.</a:t>
             </a:r>
           </a:p>
         </p:txBody>
@@ -3700,7 +3688,7 @@
               </a:defRPr>
             </a:pPr>
             <a:r>
-              <a:t>Definición:</a:t>
+              <a:t>Definición (Sharda et al., 2020):</a:t>
             </a:r>
           </a:p>
           <a:p>
@@ -3713,11 +3701,10 @@
               </a:defRPr>
             </a:pPr>
             <a:r>
-              <a:t>Es un conjunto de estrategias, procesos, aplicaciones, datos y tecnologías enfocadas en la administración y creación de conocimiento.</a:t>
-            </a:r>
-          </a:p>
-          <a:p>
-            <a:br/>
+              <a:t>Conjunto de estrategias, procesos y tecnologías enfocadas en la creación de conocimiento mediante análisis de datos.</a:t>
+            </a:r>
+          </a:p>
+          <a:p>
             <a:pPr>
               <a:defRPr sz="3200" b="1">
                 <a:solidFill>
@@ -3727,7 +3714,7 @@
               </a:defRPr>
             </a:pPr>
             <a:r>
-              <a:t>Objetivo Principal:</a:t>
+              <a:t>El rol de la Analítica:</a:t>
             </a:r>
           </a:p>
           <a:p>
@@ -3740,7 +3727,33 @@
               </a:defRPr>
             </a:pPr>
             <a:r>
-              <a:t>Convertir datos crudos en información accionable para la toma de decisiones.</a:t>
+              <a:t>- Descriptiva: ¿Qué sucedió? (Reportes históricos)</a:t>
+            </a:r>
+          </a:p>
+          <a:p>
+            <a:pPr lvl="1">
+              <a:defRPr sz="2800" b="0">
+                <a:solidFill>
+                  <a:srgbClr val="003865"/>
+                </a:solidFill>
+                <a:latin typeface="Century Gothic"/>
+              </a:defRPr>
+            </a:pPr>
+            <a:r>
+              <a:t>- Predictiva: ¿Qué pasará? (Pronósticos, ML)</a:t>
+            </a:r>
+          </a:p>
+          <a:p>
+            <a:pPr lvl="1">
+              <a:defRPr sz="2800" b="0">
+                <a:solidFill>
+                  <a:srgbClr val="003865"/>
+                </a:solidFill>
+                <a:latin typeface="Century Gothic"/>
+              </a:defRPr>
+            </a:pPr>
+            <a:r>
+              <a:t>- Prescriptiva: ¿Qué debemos hacer? (Optimización)</a:t>
             </a:r>
           </a:p>
         </p:txBody>
@@ -3801,7 +3814,7 @@
                 </a:solidFill>
                 <a:latin typeface="Century Gothic"/>
               </a:rPr>
-              <a:t>Evolución del BI</a:t>
+              <a:t>Glosario Técnico de BI</a:t>
             </a:r>
           </a:p>
         </p:txBody>
@@ -3875,7 +3888,7 @@
           <a:p/>
           <a:p>
             <a:pPr>
-              <a:defRPr sz="2800" b="1">
+              <a:defRPr sz="2600" b="1">
                 <a:solidFill>
                   <a:srgbClr val="003865"/>
                 </a:solidFill>
@@ -3883,12 +3896,12 @@
               </a:defRPr>
             </a:pPr>
             <a:r>
-              <a:t>BI Tradicional (1.0):</a:t>
+              <a:t>ETL (Extract, Transform, Load):</a:t>
             </a:r>
           </a:p>
           <a:p>
             <a:pPr lvl="1">
-              <a:defRPr sz="2400" b="0">
+              <a:defRPr sz="2200" b="0">
                 <a:solidFill>
                   <a:srgbClr val="003865"/>
                 </a:solidFill>
@@ -3896,13 +3909,12 @@
               </a:defRPr>
             </a:pPr>
             <a:r>
-              <a:t>Generación de reportes estáticos por el departamento de TI.</a:t>
-            </a:r>
-          </a:p>
-          <a:p>
-            <a:br/>
+              <a:t>Extraer datos, transformarlos al formato analítico y cargarlos.</a:t>
+            </a:r>
+          </a:p>
+          <a:p>
             <a:pPr>
-              <a:defRPr sz="2800" b="1">
+              <a:defRPr sz="2600" b="1">
                 <a:solidFill>
                   <a:srgbClr val="003865"/>
                 </a:solidFill>
@@ -3910,12 +3922,12 @@
               </a:defRPr>
             </a:pPr>
             <a:r>
-              <a:t>Self-Service BI (2.0):</a:t>
+              <a:t>OLTP vs OLAP:</a:t>
             </a:r>
           </a:p>
           <a:p>
             <a:pPr lvl="1">
-              <a:defRPr sz="2400" b="0">
+              <a:defRPr sz="2200" b="0">
                 <a:solidFill>
                   <a:srgbClr val="003865"/>
                 </a:solidFill>
@@ -3923,13 +3935,25 @@
               </a:defRPr>
             </a:pPr>
             <a:r>
-              <a:t>Analistas explorando datos con herramientas como Power BI / Tableau.</a:t>
-            </a:r>
-          </a:p>
-          <a:p>
-            <a:br/>
+              <a:t>OLTP: Transacciones rápidas diarias (Ej. Caja Registradora).</a:t>
+            </a:r>
+          </a:p>
+          <a:p>
+            <a:pPr lvl="1">
+              <a:defRPr sz="2200" b="0">
+                <a:solidFill>
+                  <a:srgbClr val="003865"/>
+                </a:solidFill>
+                <a:latin typeface="Century Gothic"/>
+              </a:defRPr>
+            </a:pPr>
+            <a:r>
+              <a:t>OLAP: Consultas analíticas multidimensionales (Cubo de Datos).</a:t>
+            </a:r>
+          </a:p>
+          <a:p>
             <a:pPr>
-              <a:defRPr sz="2800" b="1">
+              <a:defRPr sz="2600" b="1">
                 <a:solidFill>
                   <a:srgbClr val="003865"/>
                 </a:solidFill>
@@ -3937,12 +3961,12 @@
               </a:defRPr>
             </a:pPr>
             <a:r>
-              <a:t>Augmented BI (3.0):</a:t>
+              <a:t>Data Warehouse &amp; Data Mart:</a:t>
             </a:r>
           </a:p>
           <a:p>
             <a:pPr lvl="1">
-              <a:defRPr sz="2400" b="0">
+              <a:defRPr sz="2200" b="0">
                 <a:solidFill>
                   <a:srgbClr val="003865"/>
                 </a:solidFill>
@@ -3950,7 +3974,7 @@
               </a:defRPr>
             </a:pPr>
             <a:r>
-              <a:t>Integración de Machine Learning y NLP para descubrir insights automáticamente.</a:t>
+              <a:t>Repositorio centralizado de datos (Warehouse) y sus subdivisiones por área (Marts).</a:t>
             </a:r>
           </a:p>
         </p:txBody>
@@ -4087,26 +4111,26 @@
             <a:pPr>
               <a:defRPr sz="3200" b="1">
                 <a:solidFill>
+                  <a:srgbClr val="E85C0B"/>
+                </a:solidFill>
+                <a:latin typeface="Century Gothic"/>
+              </a:defRPr>
+            </a:pPr>
+            <a:r>
+              <a:t>Principios de Diseño Visual (Knaflic, 2015):</a:t>
+            </a:r>
+          </a:p>
+          <a:p>
+            <a:pPr>
+              <a:defRPr sz="2800" b="1">
+                <a:solidFill>
                   <a:srgbClr val="003865"/>
                 </a:solidFill>
                 <a:latin typeface="Century Gothic"/>
               </a:defRPr>
             </a:pPr>
             <a:r>
-              <a:t>El poder de una buena historia (Knaflic, 2015):</a:t>
-            </a:r>
-          </a:p>
-          <a:p>
-            <a:pPr lvl="1">
-              <a:defRPr sz="2800" b="0">
-                <a:solidFill>
-                  <a:srgbClr val="003865"/>
-                </a:solidFill>
-                <a:latin typeface="Century Gothic"/>
-              </a:defRPr>
-            </a:pPr>
-            <a:r>
-              <a:t>No basta con tener datos; hay que saber comunicarlos.</a:t>
+              <a:t>1. Eliminar el desorden (Declutter):</a:t>
             </a:r>
           </a:p>
           <a:p>
@@ -4119,7 +4143,20 @@
               </a:defRPr>
             </a:pPr>
             <a:r>
-              <a:t>1. Entiende a tu audiencia y el contexto.</a:t>
+              <a:t>Quita bordes, gridlines y fondos que no sumen información.</a:t>
+            </a:r>
+          </a:p>
+          <a:p>
+            <a:pPr>
+              <a:defRPr sz="2800" b="1">
+                <a:solidFill>
+                  <a:srgbClr val="003865"/>
+                </a:solidFill>
+                <a:latin typeface="Century Gothic"/>
+              </a:defRPr>
+            </a:pPr>
+            <a:r>
+              <a:t>2. Dirigir la Atención:</a:t>
             </a:r>
           </a:p>
           <a:p>
@@ -4132,7 +4169,20 @@
               </a:defRPr>
             </a:pPr>
             <a:r>
-              <a:t>2. Elige la presentación visual más adecuada.</a:t>
+              <a:t>Usa colores vibrantes (naranja) SOLO para los datos clave. El resto en tonos neutros (gris/azul).</a:t>
+            </a:r>
+          </a:p>
+          <a:p>
+            <a:pPr>
+              <a:defRPr sz="2800" b="1">
+                <a:solidFill>
+                  <a:srgbClr val="003865"/>
+                </a:solidFill>
+                <a:latin typeface="Century Gothic"/>
+              </a:defRPr>
+            </a:pPr>
+            <a:r>
+              <a:t>3. Evitar el 3D:</a:t>
             </a:r>
           </a:p>
           <a:p>
@@ -4145,20 +4195,7 @@
               </a:defRPr>
             </a:pPr>
             <a:r>
-              <a:t>3. Elimina el desorden visual (Declutter).</a:t>
-            </a:r>
-          </a:p>
-          <a:p>
-            <a:pPr lvl="1">
-              <a:defRPr sz="2400" b="0">
-                <a:solidFill>
-                  <a:srgbClr val="003865"/>
-                </a:solidFill>
-                <a:latin typeface="Century Gothic"/>
-              </a:defRPr>
-            </a:pPr>
-            <a:r>
-              <a:t>4. Dirige la atención donde realmente importa.</a:t>
+              <a:t>Los gráficos 3D (especialmente Pie Charts) distorsionan las proporciones reales.</a:t>
             </a:r>
           </a:p>
         </p:txBody>
@@ -4219,7 +4256,7 @@
                 </a:solidFill>
                 <a:latin typeface="Century Gothic"/>
               </a:rPr>
-              <a:t>Taller: Pair Programming</a:t>
+              <a:t>Ejemplo Práctico: Dashboards</a:t>
             </a:r>
           </a:p>
         </p:txBody>
@@ -4295,13 +4332,13 @@
             <a:pPr>
               <a:defRPr sz="3200" b="1">
                 <a:solidFill>
-                  <a:srgbClr val="E85C0B"/>
+                  <a:srgbClr val="003865"/>
                 </a:solidFill>
                 <a:latin typeface="Century Gothic"/>
               </a:defRPr>
             </a:pPr>
             <a:r>
-              <a:t>Exploración de Casos de Éxito en Empresas Data-Driven</a:t>
+              <a:t>¿Qué hace a un Dashboard excelente?</a:t>
             </a:r>
           </a:p>
           <a:p>
@@ -4314,7 +4351,7 @@
               </a:defRPr>
             </a:pPr>
             <a:r>
-              <a:t>1. Elijan una empresa (Netflix, Zara, Spotify, Amazon).</a:t>
+              <a:t>Jerarquía visual: Lo más importante (KPIs globales) va arriba a la izquierda.</a:t>
             </a:r>
           </a:p>
           <a:p>
@@ -4327,7 +4364,7 @@
               </a:defRPr>
             </a:pPr>
             <a:r>
-              <a:t>2. Investiguen qué tipo de datos recolectan (estructurados vs no estructurados).</a:t>
+              <a:t>Ley de Proximidad (Gestalt): Gráficos de un mismo tema deben agruparse espacialmente.</a:t>
             </a:r>
           </a:p>
           <a:p>
@@ -4340,7 +4377,150 @@
               </a:defRPr>
             </a:pPr>
             <a:r>
-              <a:t>3. Analicen cómo usan esos datos para tomar decisiones.</a:t>
+              <a:t>Menos es más: Un gerente tiene 5 segundos para entender si la empresa va bien o mal.</a:t>
+            </a:r>
+          </a:p>
+        </p:txBody>
+      </p:sp>
+    </p:spTree>
+  </p:cSld>
+  <p:clrMapOvr>
+    <a:masterClrMapping/>
+  </p:clrMapOvr>
+</p:sld>
+</file>
+
+<file path=ppt/slides/slide8.xml><?xml version="1.0" encoding="utf-8"?>
+<p:sld xmlns:a="http://schemas.openxmlformats.org/drawingml/2006/main" xmlns:p="http://schemas.openxmlformats.org/presentationml/2006/main" xmlns:r="http://schemas.openxmlformats.org/officeDocument/2006/relationships">
+  <p:cSld>
+    <p:bg>
+      <p:bgPr>
+        <a:solidFill>
+          <a:srgbClr val="F0F0F0"/>
+        </a:solidFill>
+        <a:effectLst/>
+      </p:bgPr>
+    </p:bg>
+    <p:spTree>
+      <p:nvGrpSpPr>
+        <p:cNvPr id="1" name=""/>
+        <p:cNvGrpSpPr/>
+        <p:nvPr/>
+      </p:nvGrpSpPr>
+      <p:grpSpPr/>
+      <p:sp>
+        <p:nvSpPr>
+          <p:cNvPr id="2" name="TextBox 1"/>
+          <p:cNvSpPr txBox="1"/>
+          <p:nvPr/>
+        </p:nvSpPr>
+        <p:spPr>
+          <a:xfrm>
+            <a:off x="457200" y="457200"/>
+            <a:ext cx="11274552" cy="914400"/>
+          </a:xfrm>
+          <a:prstGeom prst="rect">
+            <a:avLst/>
+          </a:prstGeom>
+          <a:noFill/>
+        </p:spPr>
+        <p:txBody>
+          <a:bodyPr wrap="none">
+            <a:spAutoFit/>
+          </a:bodyPr>
+          <a:lstStyle/>
+          <a:p>
+            <a:pPr algn="l"/>
+            <a:r>
+              <a:rPr sz="4500" b="1">
+                <a:solidFill>
+                  <a:srgbClr val="003865"/>
+                </a:solidFill>
+                <a:latin typeface="Century Gothic"/>
+              </a:rPr>
+              <a:t>Taller: Pair Programming</a:t>
+            </a:r>
+          </a:p>
+        </p:txBody>
+      </p:sp>
+      <p:sp>
+        <p:nvSpPr>
+          <p:cNvPr id="3" name="Rectangle 2"/>
+          <p:cNvSpPr/>
+          <p:nvPr/>
+        </p:nvSpPr>
+        <p:spPr>
+          <a:xfrm>
+            <a:off x="457200" y="1371600"/>
+            <a:ext cx="11274552" cy="45720"/>
+          </a:xfrm>
+          <a:prstGeom prst="rect">
+            <a:avLst/>
+          </a:prstGeom>
+          <a:solidFill>
+            <a:srgbClr val="E85C0B"/>
+          </a:solidFill>
+          <a:ln>
+            <a:solidFill>
+              <a:srgbClr val="E85C0B"/>
+            </a:solidFill>
+          </a:ln>
+        </p:spPr>
+        <p:style>
+          <a:lnRef idx="1">
+            <a:schemeClr val="accent1"/>
+          </a:lnRef>
+          <a:fillRef idx="3">
+            <a:schemeClr val="accent1"/>
+          </a:fillRef>
+          <a:effectRef idx="2">
+            <a:schemeClr val="accent1"/>
+          </a:effectRef>
+          <a:fontRef idx="minor">
+            <a:schemeClr val="lt1"/>
+          </a:fontRef>
+        </p:style>
+        <p:txBody>
+          <a:bodyPr rtlCol="0" anchor="ctr"/>
+          <a:lstStyle/>
+          <a:p>
+            <a:pPr algn="ctr"/>
+          </a:p>
+        </p:txBody>
+      </p:sp>
+      <p:sp>
+        <p:nvSpPr>
+          <p:cNvPr id="4" name="TextBox 3"/>
+          <p:cNvSpPr txBox="1"/>
+          <p:nvPr/>
+        </p:nvSpPr>
+        <p:spPr>
+          <a:xfrm>
+            <a:off x="457200" y="1645920"/>
+            <a:ext cx="11274552" cy="4572000"/>
+          </a:xfrm>
+          <a:prstGeom prst="rect">
+            <a:avLst/>
+          </a:prstGeom>
+          <a:noFill/>
+        </p:spPr>
+        <p:txBody>
+          <a:bodyPr wrap="square">
+            <a:spAutoFit/>
+          </a:bodyPr>
+          <a:lstStyle/>
+          <a:p/>
+          <a:p>
+            <a:pPr>
+              <a:defRPr sz="3200" b="1">
+                <a:solidFill>
+                  <a:srgbClr val="E85C0B"/>
+                </a:solidFill>
+                <a:latin typeface="Century Gothic"/>
+              </a:defRPr>
+            </a:pPr>
+            <a:r>
+              <a:t>Análisis Crítico de Dashboards</a:t>
             </a:r>
           </a:p>
           <a:p>
@@ -4353,7 +4533,33 @@
               </a:defRPr>
             </a:pPr>
             <a:r>
-              <a:t>4. Redacten un resumen en formato Markdown y súbanlo a GitHub.</a:t>
+              <a:t>1. Busquen en internet 2 Dashboards de Ventas (Uno saturado y uno limpio).</a:t>
+            </a:r>
+          </a:p>
+          <a:p>
+            <a:pPr lvl="1">
+              <a:defRPr sz="2600" b="0">
+                <a:solidFill>
+                  <a:srgbClr val="003865"/>
+                </a:solidFill>
+                <a:latin typeface="Century Gothic"/>
+              </a:defRPr>
+            </a:pPr>
+            <a:r>
+              <a:t>2. Analicen qué principios de Gestalt y 'Decluttering' se violan en el malo.</a:t>
+            </a:r>
+          </a:p>
+          <a:p>
+            <a:pPr lvl="1">
+              <a:defRPr sz="2600" b="0">
+                <a:solidFill>
+                  <a:srgbClr val="003865"/>
+                </a:solidFill>
+                <a:latin typeface="Century Gothic"/>
+              </a:defRPr>
+            </a:pPr>
+            <a:r>
+              <a:t>3. Redacten un resumen en formato Markdown y súbanlo a GitHub.</a:t>
             </a:r>
           </a:p>
           <a:p>
@@ -4366,7 +4572,7 @@
               </a:defRPr>
             </a:pPr>
             <a:r>
-              <a:t>Usen LLMNotebook como asistente de investigación.</a:t>
+              <a:t>Usen LLMNotebook como asistente crítico para esta evaluación.</a:t>
             </a:r>
           </a:p>
         </p:txBody>

</xml_diff>

<commit_message>
feat: agrega secciones de agenda, conclusiones y bibliografia; mejora interactividad y simulacion de graficos en HTML/PPT
</commit_message>
<xml_diff>
--- a/Semanas/Semana_1/diapositivas_semana_1.pptx
+++ b/Semanas/Semana_1/diapositivas_semana_1.pptx
@@ -13,6 +13,9 @@
     <p:sldId id="261" r:id="rId12"/>
     <p:sldId id="262" r:id="rId13"/>
     <p:sldId id="263" r:id="rId14"/>
+    <p:sldId id="264" r:id="rId15"/>
+    <p:sldId id="265" r:id="rId16"/>
+    <p:sldId id="266" r:id="rId17"/>
   </p:sldIdLst>
   <p:sldSz cx="12191695" cy="6858000" type="screen4x3"/>
   <p:notesSz cx="6858000" cy="9144000"/>
@@ -3193,7 +3196,7 @@
 </p:sld>
 </file>
 
-<file path=ppt/slides/slide2.xml><?xml version="1.0" encoding="utf-8"?>
+<file path=ppt/slides/slide10.xml><?xml version="1.0" encoding="utf-8"?>
 <p:sld xmlns:a="http://schemas.openxmlformats.org/drawingml/2006/main" xmlns:p="http://schemas.openxmlformats.org/presentationml/2006/main" xmlns:r="http://schemas.openxmlformats.org/officeDocument/2006/relationships">
   <p:cSld>
     <p:bg>
@@ -3219,7 +3222,7 @@
         </p:nvSpPr>
         <p:spPr>
           <a:xfrm>
-            <a:off x="457200" y="457200"/>
+            <a:off x="457200" y="182880"/>
             <a:ext cx="11274552" cy="914400"/>
           </a:xfrm>
           <a:prstGeom prst="rect">
@@ -3235,13 +3238,13 @@
           <a:p>
             <a:pPr algn="l"/>
             <a:r>
-              <a:rPr sz="4500" b="1">
+              <a:rPr sz="4000" b="1">
                 <a:solidFill>
                   <a:srgbClr val="003865"/>
                 </a:solidFill>
                 <a:latin typeface="Century Gothic"/>
               </a:rPr>
-              <a:t>Acuerdos de Clase</a:t>
+              <a:t>Conclusiones de la Sesión</a:t>
             </a:r>
           </a:p>
         </p:txBody>
@@ -3254,7 +3257,7 @@
         </p:nvSpPr>
         <p:spPr>
           <a:xfrm>
-            <a:off x="457200" y="1371600"/>
+            <a:off x="457200" y="1097280"/>
             <a:ext cx="11274552" cy="45720"/>
           </a:xfrm>
           <a:prstGeom prst="rect">
@@ -3299,8 +3302,8 @@
         </p:nvSpPr>
         <p:spPr>
           <a:xfrm>
-            <a:off x="457200" y="1645920"/>
-            <a:ext cx="11274552" cy="4572000"/>
+            <a:off x="457200" y="1280160"/>
+            <a:ext cx="11274552" cy="5303520"/>
           </a:xfrm>
           <a:prstGeom prst="rect">
             <a:avLst/>
@@ -3315,6 +3318,9 @@
           <a:p/>
           <a:p>
             <a:pPr>
+              <a:spcAft>
+                <a:spcPts val="1000"/>
+              </a:spcAft>
               <a:defRPr sz="2800" b="1">
                 <a:solidFill>
                   <a:srgbClr val="003865"/>
@@ -3323,11 +3329,14 @@
               </a:defRPr>
             </a:pPr>
             <a:r>
-              <a:t>Horario Oficial: Viernes de 10:00 AM a 1:00 PM.</a:t>
+              <a:t>El BI no es solo tecnología, es una herramienta estratégica:</a:t>
             </a:r>
           </a:p>
           <a:p>
             <a:pPr lvl="1">
+              <a:spcAft>
+                <a:spcPts val="1000"/>
+              </a:spcAft>
               <a:defRPr sz="2400" b="0">
                 <a:solidFill>
                   <a:srgbClr val="003865"/>
@@ -3336,11 +3345,30 @@
               </a:defRPr>
             </a:pPr>
             <a:r>
-              <a:t>Puntualidad: Llegar a tiempo garantiza no perder conceptos clave.</a:t>
+              <a:t>El verdadero valor del BI está en pasar de los datos descriptivos (pasado) a las decisiones prescriptivas (acciones).</a:t>
+            </a:r>
+          </a:p>
+          <a:p>
+            <a:pPr>
+              <a:spcAft>
+                <a:spcPts val="1000"/>
+              </a:spcAft>
+              <a:defRPr sz="2800" b="1">
+                <a:solidFill>
+                  <a:srgbClr val="003865"/>
+                </a:solidFill>
+                <a:latin typeface="Century Gothic"/>
+              </a:defRPr>
+            </a:pPr>
+            <a:r>
+              <a:t>El diseño visual importa tanto como el modelo de datos:</a:t>
             </a:r>
           </a:p>
           <a:p>
             <a:pPr lvl="1">
+              <a:spcAft>
+                <a:spcPts val="1000"/>
+              </a:spcAft>
               <a:defRPr sz="2400" b="0">
                 <a:solidFill>
                   <a:srgbClr val="003865"/>
@@ -3349,20 +3377,7 @@
               </a:defRPr>
             </a:pPr>
             <a:r>
-              <a:t>Descansos Cognitivos: Haremos una pausa a las 11:30 AM.</a:t>
-            </a:r>
-          </a:p>
-          <a:p>
-            <a:pPr lvl="1">
-              <a:defRPr sz="2400" b="0">
-                <a:solidFill>
-                  <a:srgbClr val="003865"/>
-                </a:solidFill>
-                <a:latin typeface="Century Gothic"/>
-              </a:defRPr>
-            </a:pPr>
-            <a:r>
-              <a:t>Estrategia EMI: 10 minutos de inmersión en inglés por sesión.</a:t>
+              <a:t>Un modelo perfecto (Data Warehouse robusto) fracasa si el Dashboard es ilegible (Exceso de Clutter).</a:t>
             </a:r>
           </a:p>
         </p:txBody>
@@ -3375,7 +3390,7 @@
 </p:sld>
 </file>
 
-<file path=ppt/slides/slide3.xml><?xml version="1.0" encoding="utf-8"?>
+<file path=ppt/slides/slide11.xml><?xml version="1.0" encoding="utf-8"?>
 <p:sld xmlns:a="http://schemas.openxmlformats.org/drawingml/2006/main" xmlns:p="http://schemas.openxmlformats.org/presentationml/2006/main" xmlns:r="http://schemas.openxmlformats.org/officeDocument/2006/relationships">
   <p:cSld>
     <p:bg>
@@ -3401,7 +3416,7 @@
         </p:nvSpPr>
         <p:spPr>
           <a:xfrm>
-            <a:off x="457200" y="457200"/>
+            <a:off x="457200" y="182880"/>
             <a:ext cx="11274552" cy="914400"/>
           </a:xfrm>
           <a:prstGeom prst="rect">
@@ -3417,13 +3432,13 @@
           <a:p>
             <a:pPr algn="l"/>
             <a:r>
-              <a:rPr sz="4500" b="1">
+              <a:rPr sz="4000" b="1">
                 <a:solidFill>
                   <a:srgbClr val="003865"/>
                 </a:solidFill>
                 <a:latin typeface="Century Gothic"/>
               </a:rPr>
-              <a:t>🇬🇧 EMI Strategy: Warm-Up</a:t>
+              <a:t>Bibliografía y Referencias</a:t>
             </a:r>
           </a:p>
         </p:txBody>
@@ -3436,7 +3451,7 @@
         </p:nvSpPr>
         <p:spPr>
           <a:xfrm>
-            <a:off x="457200" y="1371600"/>
+            <a:off x="457200" y="1097280"/>
             <a:ext cx="11274552" cy="45720"/>
           </a:xfrm>
           <a:prstGeom prst="rect">
@@ -3481,8 +3496,8 @@
         </p:nvSpPr>
         <p:spPr>
           <a:xfrm>
-            <a:off x="457200" y="1645920"/>
-            <a:ext cx="11274552" cy="4572000"/>
+            <a:off x="457200" y="1280160"/>
+            <a:ext cx="11274552" cy="5303520"/>
           </a:xfrm>
           <a:prstGeom prst="rect">
             <a:avLst/>
@@ -3497,7 +3512,26 @@
           <a:p/>
           <a:p>
             <a:pPr>
-              <a:defRPr sz="3600" b="1">
+              <a:spcAft>
+                <a:spcPts val="1000"/>
+              </a:spcAft>
+              <a:defRPr sz="2800" b="1">
+                <a:solidFill>
+                  <a:srgbClr val="E85C0B"/>
+                </a:solidFill>
+                <a:latin typeface="Century Gothic"/>
+              </a:defRPr>
+            </a:pPr>
+            <a:r>
+              <a:t>Lecturas Obligatorias:</a:t>
+            </a:r>
+          </a:p>
+          <a:p>
+            <a:pPr lvl="1">
+              <a:spcAft>
+                <a:spcPts val="1000"/>
+              </a:spcAft>
+              <a:defRPr sz="2200" b="0">
                 <a:solidFill>
                   <a:srgbClr val="003865"/>
                 </a:solidFill>
@@ -3505,13 +3539,48 @@
               </a:defRPr>
             </a:pPr>
             <a:r>
-              <a:t>Let's activate our English and BI Vocabulary!</a:t>
+              <a:t>1. Sharda, R., Delen, D., &amp; Turban, E. (2020). Business Intelligence, Analytics, and Data Science: A Managerial Perspective (4th Edition). Pearson.</a:t>
+            </a:r>
+          </a:p>
+          <a:p>
+            <a:pPr lvl="1">
+              <a:spcAft>
+                <a:spcPts val="1000"/>
+              </a:spcAft>
+              <a:defRPr sz="2200" b="0">
+                <a:solidFill>
+                  <a:srgbClr val="003865"/>
+                </a:solidFill>
+                <a:latin typeface="Century Gothic"/>
+              </a:defRPr>
+            </a:pPr>
+            <a:r>
+              <a:t>2. Knaflic, C. N. (2015). Storytelling with Data: A Data Visualization Guide for Business Professionals. Wiley.</a:t>
             </a:r>
           </a:p>
           <a:p>
             <a:br/>
             <a:pPr>
-              <a:defRPr sz="3200" b="0">
+              <a:spcAft>
+                <a:spcPts val="1000"/>
+              </a:spcAft>
+              <a:defRPr sz="2800" b="1">
+                <a:solidFill>
+                  <a:srgbClr val="E85C0B"/>
+                </a:solidFill>
+                <a:latin typeface="Century Gothic"/>
+              </a:defRPr>
+            </a:pPr>
+            <a:r>
+              <a:t>Recursos Adicionales:</a:t>
+            </a:r>
+          </a:p>
+          <a:p>
+            <a:pPr lvl="1">
+              <a:spcAft>
+                <a:spcPts val="1000"/>
+              </a:spcAft>
+              <a:defRPr sz="2200" b="0">
                 <a:solidFill>
                   <a:srgbClr val="003865"/>
                 </a:solidFill>
@@ -3519,33 +3588,7 @@
               </a:defRPr>
             </a:pPr>
             <a:r>
-              <a:t>Actividad Interactiva:</a:t>
-            </a:r>
-          </a:p>
-          <a:p>
-            <a:pPr lvl="1">
-              <a:defRPr sz="3000" b="1">
-                <a:solidFill>
-                  <a:srgbClr val="E85C0B"/>
-                </a:solidFill>
-                <a:latin typeface="Century Gothic"/>
-              </a:defRPr>
-            </a:pPr>
-            <a:r>
-              <a:t>Abran el archivo quiz_semana_1.html en sus navegadores.</a:t>
-            </a:r>
-          </a:p>
-          <a:p>
-            <a:pPr lvl="1">
-              <a:defRPr sz="2600" b="0">
-                <a:solidFill>
-                  <a:srgbClr val="003865"/>
-                </a:solidFill>
-                <a:latin typeface="Century Gothic"/>
-              </a:defRPr>
-            </a:pPr>
-            <a:r>
-              <a:t>Vamos a emparejar los conceptos (Dashboard, KPI, Data-Driven) con su definición.</a:t>
+              <a:t>Repositorio del curso: https://github.com/dudbil/Inteligencia-de-negocios-UNAB</a:t>
             </a:r>
           </a:p>
         </p:txBody>
@@ -3558,7 +3601,7 @@
 </p:sld>
 </file>
 
-<file path=ppt/slides/slide4.xml><?xml version="1.0" encoding="utf-8"?>
+<file path=ppt/slides/slide2.xml><?xml version="1.0" encoding="utf-8"?>
 <p:sld xmlns:a="http://schemas.openxmlformats.org/drawingml/2006/main" xmlns:p="http://schemas.openxmlformats.org/presentationml/2006/main" xmlns:r="http://schemas.openxmlformats.org/officeDocument/2006/relationships">
   <p:cSld>
     <p:bg>
@@ -3584,7 +3627,7 @@
         </p:nvSpPr>
         <p:spPr>
           <a:xfrm>
-            <a:off x="457200" y="457200"/>
+            <a:off x="457200" y="182880"/>
             <a:ext cx="11274552" cy="914400"/>
           </a:xfrm>
           <a:prstGeom prst="rect">
@@ -3600,13 +3643,13 @@
           <a:p>
             <a:pPr algn="l"/>
             <a:r>
-              <a:rPr sz="4500" b="1">
+              <a:rPr sz="4000" b="1">
                 <a:solidFill>
                   <a:srgbClr val="003865"/>
                 </a:solidFill>
                 <a:latin typeface="Century Gothic"/>
               </a:rPr>
-              <a:t>¿Qué es la Inteligencia de Negocios?</a:t>
+              <a:t>Agenda de la Sesión</a:t>
             </a:r>
           </a:p>
         </p:txBody>
@@ -3619,7 +3662,7 @@
         </p:nvSpPr>
         <p:spPr>
           <a:xfrm>
-            <a:off x="457200" y="1371600"/>
+            <a:off x="457200" y="1097280"/>
             <a:ext cx="11274552" cy="45720"/>
           </a:xfrm>
           <a:prstGeom prst="rect">
@@ -3664,8 +3707,8 @@
         </p:nvSpPr>
         <p:spPr>
           <a:xfrm>
-            <a:off x="457200" y="1645920"/>
-            <a:ext cx="11274552" cy="4572000"/>
+            <a:off x="457200" y="1280160"/>
+            <a:ext cx="11274552" cy="5303520"/>
           </a:xfrm>
           <a:prstGeom prst="rect">
             <a:avLst/>
@@ -3680,33 +3723,42 @@
           <a:p/>
           <a:p>
             <a:pPr>
-              <a:defRPr sz="3200" b="1">
-                <a:solidFill>
-                  <a:srgbClr val="003865"/>
+              <a:spcAft>
+                <a:spcPts val="1000"/>
+              </a:spcAft>
+              <a:defRPr sz="2800" b="1">
+                <a:solidFill>
+                  <a:srgbClr val="E85C0B"/>
                 </a:solidFill>
                 <a:latin typeface="Century Gothic"/>
               </a:defRPr>
             </a:pPr>
             <a:r>
-              <a:t>Definición (Sharda et al., 2020):</a:t>
-            </a:r>
-          </a:p>
-          <a:p>
-            <a:pPr lvl="1">
-              <a:defRPr sz="2800" b="0">
-                <a:solidFill>
-                  <a:srgbClr val="003865"/>
+              <a:t>1. Acuerdos y Reglas de Clase</a:t>
+            </a:r>
+          </a:p>
+          <a:p>
+            <a:pPr>
+              <a:spcAft>
+                <a:spcPts val="1000"/>
+              </a:spcAft>
+              <a:defRPr sz="2800" b="1">
+                <a:solidFill>
+                  <a:srgbClr val="E85C0B"/>
                 </a:solidFill>
                 <a:latin typeface="Century Gothic"/>
               </a:defRPr>
             </a:pPr>
             <a:r>
-              <a:t>Conjunto de estrategias, procesos y tecnologías enfocadas en la creación de conocimiento mediante análisis de datos.</a:t>
+              <a:t>2. Estrategia EMI (Warm-up en Inglés)</a:t>
             </a:r>
           </a:p>
           <a:p>
             <a:pPr>
-              <a:defRPr sz="3200" b="1">
+              <a:spcAft>
+                <a:spcPts val="1000"/>
+              </a:spcAft>
+              <a:defRPr sz="2800" b="1">
                 <a:solidFill>
                   <a:srgbClr val="E85C0B"/>
                 </a:solidFill>
@@ -3714,46 +3766,71 @@
               </a:defRPr>
             </a:pPr>
             <a:r>
-              <a:t>El rol de la Analítica:</a:t>
-            </a:r>
-          </a:p>
-          <a:p>
-            <a:pPr lvl="1">
-              <a:defRPr sz="2800" b="0">
-                <a:solidFill>
-                  <a:srgbClr val="003865"/>
+              <a:t>3. ¿Qué es Inteligencia de Negocios (BI)?</a:t>
+            </a:r>
+          </a:p>
+          <a:p>
+            <a:pPr>
+              <a:spcAft>
+                <a:spcPts val="1000"/>
+              </a:spcAft>
+              <a:defRPr sz="2800" b="1">
+                <a:solidFill>
+                  <a:srgbClr val="E85C0B"/>
                 </a:solidFill>
                 <a:latin typeface="Century Gothic"/>
               </a:defRPr>
             </a:pPr>
             <a:r>
-              <a:t>- Descriptiva: ¿Qué sucedió? (Reportes históricos)</a:t>
-            </a:r>
-          </a:p>
-          <a:p>
-            <a:pPr lvl="1">
-              <a:defRPr sz="2800" b="0">
-                <a:solidFill>
-                  <a:srgbClr val="003865"/>
+              <a:t>4. Glosario Técnico y Fundamentos Analíticos</a:t>
+            </a:r>
+          </a:p>
+          <a:p>
+            <a:pPr>
+              <a:spcAft>
+                <a:spcPts val="1000"/>
+              </a:spcAft>
+              <a:defRPr sz="2800" b="1">
+                <a:solidFill>
+                  <a:srgbClr val="E85C0B"/>
                 </a:solidFill>
                 <a:latin typeface="Century Gothic"/>
               </a:defRPr>
             </a:pPr>
             <a:r>
-              <a:t>- Predictiva: ¿Qué pasará? (Pronósticos, ML)</a:t>
-            </a:r>
-          </a:p>
-          <a:p>
-            <a:pPr lvl="1">
-              <a:defRPr sz="2800" b="0">
-                <a:solidFill>
-                  <a:srgbClr val="003865"/>
+              <a:t>5. Storytelling with Data (Knaflic)</a:t>
+            </a:r>
+          </a:p>
+          <a:p>
+            <a:pPr>
+              <a:spcAft>
+                <a:spcPts val="1000"/>
+              </a:spcAft>
+              <a:defRPr sz="2800" b="1">
+                <a:solidFill>
+                  <a:srgbClr val="E85C0B"/>
                 </a:solidFill>
                 <a:latin typeface="Century Gothic"/>
               </a:defRPr>
             </a:pPr>
             <a:r>
-              <a:t>- Prescriptiva: ¿Qué debemos hacer? (Optimización)</a:t>
+              <a:t>6. Taller Práctico: Pair Programming</a:t>
+            </a:r>
+          </a:p>
+          <a:p>
+            <a:pPr>
+              <a:spcAft>
+                <a:spcPts val="1000"/>
+              </a:spcAft>
+              <a:defRPr sz="2800" b="1">
+                <a:solidFill>
+                  <a:srgbClr val="E85C0B"/>
+                </a:solidFill>
+                <a:latin typeface="Century Gothic"/>
+              </a:defRPr>
+            </a:pPr>
+            <a:r>
+              <a:t>7. Conclusiones y Bibliografía</a:t>
             </a:r>
           </a:p>
         </p:txBody>
@@ -3766,7 +3843,7 @@
 </p:sld>
 </file>
 
-<file path=ppt/slides/slide5.xml><?xml version="1.0" encoding="utf-8"?>
+<file path=ppt/slides/slide3.xml><?xml version="1.0" encoding="utf-8"?>
 <p:sld xmlns:a="http://schemas.openxmlformats.org/drawingml/2006/main" xmlns:p="http://schemas.openxmlformats.org/presentationml/2006/main" xmlns:r="http://schemas.openxmlformats.org/officeDocument/2006/relationships">
   <p:cSld>
     <p:bg>
@@ -3792,7 +3869,7 @@
         </p:nvSpPr>
         <p:spPr>
           <a:xfrm>
-            <a:off x="457200" y="457200"/>
+            <a:off x="457200" y="182880"/>
             <a:ext cx="11274552" cy="914400"/>
           </a:xfrm>
           <a:prstGeom prst="rect">
@@ -3808,13 +3885,13 @@
           <a:p>
             <a:pPr algn="l"/>
             <a:r>
-              <a:rPr sz="4500" b="1">
+              <a:rPr sz="4000" b="1">
                 <a:solidFill>
                   <a:srgbClr val="003865"/>
                 </a:solidFill>
                 <a:latin typeface="Century Gothic"/>
               </a:rPr>
-              <a:t>Glosario Técnico de BI</a:t>
+              <a:t>Acuerdos de Clase</a:t>
             </a:r>
           </a:p>
         </p:txBody>
@@ -3827,7 +3904,7 @@
         </p:nvSpPr>
         <p:spPr>
           <a:xfrm>
-            <a:off x="457200" y="1371600"/>
+            <a:off x="457200" y="1097280"/>
             <a:ext cx="11274552" cy="45720"/>
           </a:xfrm>
           <a:prstGeom prst="rect">
@@ -3872,8 +3949,8 @@
         </p:nvSpPr>
         <p:spPr>
           <a:xfrm>
-            <a:off x="457200" y="1645920"/>
-            <a:ext cx="11274552" cy="4572000"/>
+            <a:off x="457200" y="1280160"/>
+            <a:ext cx="11274552" cy="5303520"/>
           </a:xfrm>
           <a:prstGeom prst="rect">
             <a:avLst/>
@@ -3888,6 +3965,9 @@
           <a:p/>
           <a:p>
             <a:pPr>
+              <a:spcAft>
+                <a:spcPts val="1000"/>
+              </a:spcAft>
               <a:defRPr sz="2600" b="1">
                 <a:solidFill>
                   <a:srgbClr val="003865"/>
@@ -3896,11 +3976,14 @@
               </a:defRPr>
             </a:pPr>
             <a:r>
-              <a:t>ETL (Extract, Transform, Load):</a:t>
+              <a:t>Horario Oficial: Viernes de 10:00 AM a 1:00 PM.</a:t>
             </a:r>
           </a:p>
           <a:p>
             <a:pPr lvl="1">
+              <a:spcAft>
+                <a:spcPts val="1000"/>
+              </a:spcAft>
               <a:defRPr sz="2200" b="0">
                 <a:solidFill>
                   <a:srgbClr val="003865"/>
@@ -3909,12 +3992,15 @@
               </a:defRPr>
             </a:pPr>
             <a:r>
-              <a:t>Extraer datos, transformarlos al formato analítico y cargarlos.</a:t>
-            </a:r>
-          </a:p>
-          <a:p>
-            <a:pPr>
-              <a:defRPr sz="2600" b="1">
+              <a:t>Puntualidad: Llegar a tiempo garantiza no perder conceptos clave.</a:t>
+            </a:r>
+          </a:p>
+          <a:p>
+            <a:pPr lvl="1">
+              <a:spcAft>
+                <a:spcPts val="1000"/>
+              </a:spcAft>
+              <a:defRPr sz="2200" b="0">
                 <a:solidFill>
                   <a:srgbClr val="003865"/>
                 </a:solidFill>
@@ -3922,11 +4008,14 @@
               </a:defRPr>
             </a:pPr>
             <a:r>
-              <a:t>OLTP vs OLAP:</a:t>
+              <a:t>Descansos Cognitivos: Haremos una pausa a las 11:30 AM para evitar fatiga técnica.</a:t>
             </a:r>
           </a:p>
           <a:p>
             <a:pPr lvl="1">
+              <a:spcAft>
+                <a:spcPts val="1000"/>
+              </a:spcAft>
               <a:defRPr sz="2200" b="0">
                 <a:solidFill>
                   <a:srgbClr val="003865"/>
@@ -3935,46 +4024,7 @@
               </a:defRPr>
             </a:pPr>
             <a:r>
-              <a:t>OLTP: Transacciones rápidas diarias (Ej. Caja Registradora).</a:t>
-            </a:r>
-          </a:p>
-          <a:p>
-            <a:pPr lvl="1">
-              <a:defRPr sz="2200" b="0">
-                <a:solidFill>
-                  <a:srgbClr val="003865"/>
-                </a:solidFill>
-                <a:latin typeface="Century Gothic"/>
-              </a:defRPr>
-            </a:pPr>
-            <a:r>
-              <a:t>OLAP: Consultas analíticas multidimensionales (Cubo de Datos).</a:t>
-            </a:r>
-          </a:p>
-          <a:p>
-            <a:pPr>
-              <a:defRPr sz="2600" b="1">
-                <a:solidFill>
-                  <a:srgbClr val="003865"/>
-                </a:solidFill>
-                <a:latin typeface="Century Gothic"/>
-              </a:defRPr>
-            </a:pPr>
-            <a:r>
-              <a:t>Data Warehouse &amp; Data Mart:</a:t>
-            </a:r>
-          </a:p>
-          <a:p>
-            <a:pPr lvl="1">
-              <a:defRPr sz="2200" b="0">
-                <a:solidFill>
-                  <a:srgbClr val="003865"/>
-                </a:solidFill>
-                <a:latin typeface="Century Gothic"/>
-              </a:defRPr>
-            </a:pPr>
-            <a:r>
-              <a:t>Repositorio centralizado de datos (Warehouse) y sus subdivisiones por área (Marts).</a:t>
+              <a:t>Estrategia EMI: 10 a 15 minutos de inmersión en inglés técnico por sesión.</a:t>
             </a:r>
           </a:p>
         </p:txBody>
@@ -3987,7 +4037,7 @@
 </p:sld>
 </file>
 
-<file path=ppt/slides/slide6.xml><?xml version="1.0" encoding="utf-8"?>
+<file path=ppt/slides/slide4.xml><?xml version="1.0" encoding="utf-8"?>
 <p:sld xmlns:a="http://schemas.openxmlformats.org/drawingml/2006/main" xmlns:p="http://schemas.openxmlformats.org/presentationml/2006/main" xmlns:r="http://schemas.openxmlformats.org/officeDocument/2006/relationships">
   <p:cSld>
     <p:bg>
@@ -4013,7 +4063,7 @@
         </p:nvSpPr>
         <p:spPr>
           <a:xfrm>
-            <a:off x="457200" y="457200"/>
+            <a:off x="457200" y="182880"/>
             <a:ext cx="11274552" cy="914400"/>
           </a:xfrm>
           <a:prstGeom prst="rect">
@@ -4029,13 +4079,13 @@
           <a:p>
             <a:pPr algn="l"/>
             <a:r>
-              <a:rPr sz="4500" b="1">
+              <a:rPr sz="4000" b="1">
                 <a:solidFill>
                   <a:srgbClr val="003865"/>
                 </a:solidFill>
                 <a:latin typeface="Century Gothic"/>
               </a:rPr>
-              <a:t>Storytelling con Datos</a:t>
+              <a:t>🇬🇧 EMI Strategy: Warm-Up</a:t>
             </a:r>
           </a:p>
         </p:txBody>
@@ -4048,7 +4098,7 @@
         </p:nvSpPr>
         <p:spPr>
           <a:xfrm>
-            <a:off x="457200" y="1371600"/>
+            <a:off x="457200" y="1097280"/>
             <a:ext cx="11274552" cy="45720"/>
           </a:xfrm>
           <a:prstGeom prst="rect">
@@ -4093,8 +4143,8 @@
         </p:nvSpPr>
         <p:spPr>
           <a:xfrm>
-            <a:off x="457200" y="1645920"/>
-            <a:ext cx="11274552" cy="4572000"/>
+            <a:off x="457200" y="1280160"/>
+            <a:ext cx="11274552" cy="5303520"/>
           </a:xfrm>
           <a:prstGeom prst="rect">
             <a:avLst/>
@@ -4109,20 +4159,59 @@
           <a:p/>
           <a:p>
             <a:pPr>
+              <a:spcAft>
+                <a:spcPts val="1000"/>
+              </a:spcAft>
               <a:defRPr sz="3200" b="1">
                 <a:solidFill>
+                  <a:srgbClr val="003865"/>
+                </a:solidFill>
+                <a:latin typeface="Century Gothic"/>
+              </a:defRPr>
+            </a:pPr>
+            <a:r>
+              <a:t>Let's activate our English and BI Vocabulary!</a:t>
+            </a:r>
+          </a:p>
+          <a:p>
+            <a:br/>
+            <a:pPr>
+              <a:spcAft>
+                <a:spcPts val="1000"/>
+              </a:spcAft>
+              <a:defRPr sz="2800" b="0">
+                <a:solidFill>
+                  <a:srgbClr val="003865"/>
+                </a:solidFill>
+                <a:latin typeface="Century Gothic"/>
+              </a:defRPr>
+            </a:pPr>
+            <a:r>
+              <a:t>Actividad Interactiva:</a:t>
+            </a:r>
+          </a:p>
+          <a:p>
+            <a:pPr lvl="1">
+              <a:spcAft>
+                <a:spcPts val="1000"/>
+              </a:spcAft>
+              <a:defRPr sz="2600" b="1">
+                <a:solidFill>
                   <a:srgbClr val="E85C0B"/>
                 </a:solidFill>
                 <a:latin typeface="Century Gothic"/>
               </a:defRPr>
             </a:pPr>
             <a:r>
-              <a:t>Principios de Diseño Visual (Knaflic, 2015):</a:t>
-            </a:r>
-          </a:p>
-          <a:p>
-            <a:pPr>
-              <a:defRPr sz="2800" b="1">
+              <a:t>Abran el archivo quiz_semana_1.html en sus navegadores.</a:t>
+            </a:r>
+          </a:p>
+          <a:p>
+            <a:pPr lvl="1">
+              <a:spcAft>
+                <a:spcPts val="1000"/>
+              </a:spcAft>
+              <a:defRPr sz="2200" b="0">
                 <a:solidFill>
                   <a:srgbClr val="003865"/>
                 </a:solidFill>
@@ -4130,72 +4219,7 @@
               </a:defRPr>
             </a:pPr>
             <a:r>
-              <a:t>1. Eliminar el desorden (Declutter):</a:t>
-            </a:r>
-          </a:p>
-          <a:p>
-            <a:pPr lvl="1">
-              <a:defRPr sz="2400" b="0">
-                <a:solidFill>
-                  <a:srgbClr val="003865"/>
-                </a:solidFill>
-                <a:latin typeface="Century Gothic"/>
-              </a:defRPr>
-            </a:pPr>
-            <a:r>
-              <a:t>Quita bordes, gridlines y fondos que no sumen información.</a:t>
-            </a:r>
-          </a:p>
-          <a:p>
-            <a:pPr>
-              <a:defRPr sz="2800" b="1">
-                <a:solidFill>
-                  <a:srgbClr val="003865"/>
-                </a:solidFill>
-                <a:latin typeface="Century Gothic"/>
-              </a:defRPr>
-            </a:pPr>
-            <a:r>
-              <a:t>2. Dirigir la Atención:</a:t>
-            </a:r>
-          </a:p>
-          <a:p>
-            <a:pPr lvl="1">
-              <a:defRPr sz="2400" b="0">
-                <a:solidFill>
-                  <a:srgbClr val="003865"/>
-                </a:solidFill>
-                <a:latin typeface="Century Gothic"/>
-              </a:defRPr>
-            </a:pPr>
-            <a:r>
-              <a:t>Usa colores vibrantes (naranja) SOLO para los datos clave. El resto en tonos neutros (gris/azul).</a:t>
-            </a:r>
-          </a:p>
-          <a:p>
-            <a:pPr>
-              <a:defRPr sz="2800" b="1">
-                <a:solidFill>
-                  <a:srgbClr val="003865"/>
-                </a:solidFill>
-                <a:latin typeface="Century Gothic"/>
-              </a:defRPr>
-            </a:pPr>
-            <a:r>
-              <a:t>3. Evitar el 3D:</a:t>
-            </a:r>
-          </a:p>
-          <a:p>
-            <a:pPr lvl="1">
-              <a:defRPr sz="2400" b="0">
-                <a:solidFill>
-                  <a:srgbClr val="003865"/>
-                </a:solidFill>
-                <a:latin typeface="Century Gothic"/>
-              </a:defRPr>
-            </a:pPr>
-            <a:r>
-              <a:t>Los gráficos 3D (especialmente Pie Charts) distorsionan las proporciones reales.</a:t>
+              <a:t>Vamos a emparejar los conceptos (Dashboard, KPI, Data-Driven) con su definición.</a:t>
             </a:r>
           </a:p>
         </p:txBody>
@@ -4208,7 +4232,7 @@
 </p:sld>
 </file>
 
-<file path=ppt/slides/slide7.xml><?xml version="1.0" encoding="utf-8"?>
+<file path=ppt/slides/slide5.xml><?xml version="1.0" encoding="utf-8"?>
 <p:sld xmlns:a="http://schemas.openxmlformats.org/drawingml/2006/main" xmlns:p="http://schemas.openxmlformats.org/presentationml/2006/main" xmlns:r="http://schemas.openxmlformats.org/officeDocument/2006/relationships">
   <p:cSld>
     <p:bg>
@@ -4234,7 +4258,7 @@
         </p:nvSpPr>
         <p:spPr>
           <a:xfrm>
-            <a:off x="457200" y="457200"/>
+            <a:off x="457200" y="182880"/>
             <a:ext cx="11274552" cy="914400"/>
           </a:xfrm>
           <a:prstGeom prst="rect">
@@ -4250,13 +4274,13 @@
           <a:p>
             <a:pPr algn="l"/>
             <a:r>
-              <a:rPr sz="4500" b="1">
+              <a:rPr sz="4000" b="1">
                 <a:solidFill>
                   <a:srgbClr val="003865"/>
                 </a:solidFill>
                 <a:latin typeface="Century Gothic"/>
               </a:rPr>
-              <a:t>Ejemplo Práctico: Dashboards</a:t>
+              <a:t>¿Qué es la Inteligencia de Negocios?</a:t>
             </a:r>
           </a:p>
         </p:txBody>
@@ -4269,7 +4293,7 @@
         </p:nvSpPr>
         <p:spPr>
           <a:xfrm>
-            <a:off x="457200" y="1371600"/>
+            <a:off x="457200" y="1097280"/>
             <a:ext cx="11274552" cy="45720"/>
           </a:xfrm>
           <a:prstGeom prst="rect">
@@ -4314,8 +4338,8 @@
         </p:nvSpPr>
         <p:spPr>
           <a:xfrm>
-            <a:off x="457200" y="1645920"/>
-            <a:ext cx="11274552" cy="4572000"/>
+            <a:off x="457200" y="1280160"/>
+            <a:ext cx="11274552" cy="5303520"/>
           </a:xfrm>
           <a:prstGeom prst="rect">
             <a:avLst/>
@@ -4330,7 +4354,10 @@
           <a:p/>
           <a:p>
             <a:pPr>
-              <a:defRPr sz="3200" b="1">
+              <a:spcAft>
+                <a:spcPts val="1000"/>
+              </a:spcAft>
+              <a:defRPr sz="2800" b="1">
                 <a:solidFill>
                   <a:srgbClr val="003865"/>
                 </a:solidFill>
@@ -4338,12 +4365,15 @@
               </a:defRPr>
             </a:pPr>
             <a:r>
-              <a:t>¿Qué hace a un Dashboard excelente?</a:t>
+              <a:t>Definición Institucional (Sharda et al., 2020):</a:t>
             </a:r>
           </a:p>
           <a:p>
             <a:pPr lvl="1">
-              <a:defRPr sz="2600" b="0">
+              <a:spcAft>
+                <a:spcPts val="1000"/>
+              </a:spcAft>
+              <a:defRPr sz="2200" b="0">
                 <a:solidFill>
                   <a:srgbClr val="003865"/>
                 </a:solidFill>
@@ -4351,12 +4381,32 @@
               </a:defRPr>
             </a:pPr>
             <a:r>
-              <a:t>Jerarquía visual: Lo más importante (KPIs globales) va arriba a la izquierda.</a:t>
+              <a:t>Conjunto de estrategias, procesos y tecnologías enfocadas en la creación de conocimiento mediante análisis de datos.</a:t>
+            </a:r>
+          </a:p>
+          <a:p>
+            <a:br/>
+            <a:pPr>
+              <a:spcAft>
+                <a:spcPts val="1000"/>
+              </a:spcAft>
+              <a:defRPr sz="2800" b="1">
+                <a:solidFill>
+                  <a:srgbClr val="E85C0B"/>
+                </a:solidFill>
+                <a:latin typeface="Century Gothic"/>
+              </a:defRPr>
+            </a:pPr>
+            <a:r>
+              <a:t>El rol de la Analítica:</a:t>
             </a:r>
           </a:p>
           <a:p>
             <a:pPr lvl="1">
-              <a:defRPr sz="2600" b="0">
+              <a:spcAft>
+                <a:spcPts val="1000"/>
+              </a:spcAft>
+              <a:defRPr sz="2200" b="0">
                 <a:solidFill>
                   <a:srgbClr val="003865"/>
                 </a:solidFill>
@@ -4364,12 +4414,15 @@
               </a:defRPr>
             </a:pPr>
             <a:r>
-              <a:t>Ley de Proximidad (Gestalt): Gráficos de un mismo tema deben agruparse espacialmente.</a:t>
+              <a:t>- Descriptiva: ¿Qué sucedió? (Reportes históricos)</a:t>
             </a:r>
           </a:p>
           <a:p>
             <a:pPr lvl="1">
-              <a:defRPr sz="2600" b="0">
+              <a:spcAft>
+                <a:spcPts val="1000"/>
+              </a:spcAft>
+              <a:defRPr sz="2200" b="0">
                 <a:solidFill>
                   <a:srgbClr val="003865"/>
                 </a:solidFill>
@@ -4377,7 +4430,23 @@
               </a:defRPr>
             </a:pPr>
             <a:r>
-              <a:t>Menos es más: Un gerente tiene 5 segundos para entender si la empresa va bien o mal.</a:t>
+              <a:t>- Predictiva: ¿Qué pasará? (Modelos predictivos, Machine Learning)</a:t>
+            </a:r>
+          </a:p>
+          <a:p>
+            <a:pPr lvl="1">
+              <a:spcAft>
+                <a:spcPts val="1000"/>
+              </a:spcAft>
+              <a:defRPr sz="2200" b="0">
+                <a:solidFill>
+                  <a:srgbClr val="003865"/>
+                </a:solidFill>
+                <a:latin typeface="Century Gothic"/>
+              </a:defRPr>
+            </a:pPr>
+            <a:r>
+              <a:t>- Prescriptiva: ¿Qué debemos hacer? (Optimización, Simulación)</a:t>
             </a:r>
           </a:p>
         </p:txBody>
@@ -4390,7 +4459,7 @@
 </p:sld>
 </file>
 
-<file path=ppt/slides/slide8.xml><?xml version="1.0" encoding="utf-8"?>
+<file path=ppt/slides/slide6.xml><?xml version="1.0" encoding="utf-8"?>
 <p:sld xmlns:a="http://schemas.openxmlformats.org/drawingml/2006/main" xmlns:p="http://schemas.openxmlformats.org/presentationml/2006/main" xmlns:r="http://schemas.openxmlformats.org/officeDocument/2006/relationships">
   <p:cSld>
     <p:bg>
@@ -4416,7 +4485,7 @@
         </p:nvSpPr>
         <p:spPr>
           <a:xfrm>
-            <a:off x="457200" y="457200"/>
+            <a:off x="457200" y="182880"/>
             <a:ext cx="11274552" cy="914400"/>
           </a:xfrm>
           <a:prstGeom prst="rect">
@@ -4432,13 +4501,13 @@
           <a:p>
             <a:pPr algn="l"/>
             <a:r>
-              <a:rPr sz="4500" b="1">
+              <a:rPr sz="4000" b="1">
                 <a:solidFill>
                   <a:srgbClr val="003865"/>
                 </a:solidFill>
                 <a:latin typeface="Century Gothic"/>
               </a:rPr>
-              <a:t>Taller: Pair Programming</a:t>
+              <a:t>Glosario Técnico de BI</a:t>
             </a:r>
           </a:p>
         </p:txBody>
@@ -4451,7 +4520,7 @@
         </p:nvSpPr>
         <p:spPr>
           <a:xfrm>
-            <a:off x="457200" y="1371600"/>
+            <a:off x="457200" y="1097280"/>
             <a:ext cx="11274552" cy="45720"/>
           </a:xfrm>
           <a:prstGeom prst="rect">
@@ -4496,8 +4565,8 @@
         </p:nvSpPr>
         <p:spPr>
           <a:xfrm>
-            <a:off x="457200" y="1645920"/>
-            <a:ext cx="11274552" cy="4572000"/>
+            <a:off x="457200" y="1280160"/>
+            <a:ext cx="11274552" cy="5303520"/>
           </a:xfrm>
           <a:prstGeom prst="rect">
             <a:avLst/>
@@ -4512,7 +4581,268 @@
           <a:p/>
           <a:p>
             <a:pPr>
-              <a:defRPr sz="3200" b="1">
+              <a:spcAft>
+                <a:spcPts val="1000"/>
+              </a:spcAft>
+              <a:defRPr sz="2600" b="1">
+                <a:solidFill>
+                  <a:srgbClr val="003865"/>
+                </a:solidFill>
+                <a:latin typeface="Century Gothic"/>
+              </a:defRPr>
+            </a:pPr>
+            <a:r>
+              <a:t>ETL (Extract, Transform, Load):</a:t>
+            </a:r>
+          </a:p>
+          <a:p>
+            <a:pPr lvl="1">
+              <a:spcAft>
+                <a:spcPts val="1000"/>
+              </a:spcAft>
+              <a:defRPr sz="2000" b="0">
+                <a:solidFill>
+                  <a:srgbClr val="003865"/>
+                </a:solidFill>
+                <a:latin typeface="Century Gothic"/>
+              </a:defRPr>
+            </a:pPr>
+            <a:r>
+              <a:t>Extraer datos, transformarlos al formato analítico y cargarlos. El 80% del trabajo en BI ocurre aquí.</a:t>
+            </a:r>
+          </a:p>
+          <a:p>
+            <a:pPr>
+              <a:spcAft>
+                <a:spcPts val="1000"/>
+              </a:spcAft>
+              <a:defRPr sz="2600" b="1">
+                <a:solidFill>
+                  <a:srgbClr val="003865"/>
+                </a:solidFill>
+                <a:latin typeface="Century Gothic"/>
+              </a:defRPr>
+            </a:pPr>
+            <a:r>
+              <a:t>OLTP vs OLAP:</a:t>
+            </a:r>
+          </a:p>
+          <a:p>
+            <a:pPr lvl="1">
+              <a:spcAft>
+                <a:spcPts val="1000"/>
+              </a:spcAft>
+              <a:defRPr sz="2000" b="0">
+                <a:solidFill>
+                  <a:srgbClr val="003865"/>
+                </a:solidFill>
+                <a:latin typeface="Century Gothic"/>
+              </a:defRPr>
+            </a:pPr>
+            <a:r>
+              <a:t>OLTP: Transacciones rápidas diarias (Ej. Caja Registradora). Altamente normalizado.</a:t>
+            </a:r>
+          </a:p>
+          <a:p>
+            <a:pPr lvl="1">
+              <a:spcAft>
+                <a:spcPts val="1000"/>
+              </a:spcAft>
+              <a:defRPr sz="2000" b="0">
+                <a:solidFill>
+                  <a:srgbClr val="003865"/>
+                </a:solidFill>
+                <a:latin typeface="Century Gothic"/>
+              </a:defRPr>
+            </a:pPr>
+            <a:r>
+              <a:t>OLAP: Consultas analíticas complejas y agregaciones (Cubo de Datos).</a:t>
+            </a:r>
+          </a:p>
+          <a:p>
+            <a:pPr>
+              <a:spcAft>
+                <a:spcPts val="1000"/>
+              </a:spcAft>
+              <a:defRPr sz="2600" b="1">
+                <a:solidFill>
+                  <a:srgbClr val="003865"/>
+                </a:solidFill>
+                <a:latin typeface="Century Gothic"/>
+              </a:defRPr>
+            </a:pPr>
+            <a:r>
+              <a:t>Data Warehouse &amp; Data Mart:</a:t>
+            </a:r>
+          </a:p>
+          <a:p>
+            <a:pPr lvl="1">
+              <a:spcAft>
+                <a:spcPts val="1000"/>
+              </a:spcAft>
+              <a:defRPr sz="2000" b="0">
+                <a:solidFill>
+                  <a:srgbClr val="003865"/>
+                </a:solidFill>
+                <a:latin typeface="Century Gothic"/>
+              </a:defRPr>
+            </a:pPr>
+            <a:r>
+              <a:t>Data Warehouse: Repositorio centralizado de datos de toda la corporación.</a:t>
+            </a:r>
+          </a:p>
+          <a:p>
+            <a:pPr lvl="1">
+              <a:spcAft>
+                <a:spcPts val="1000"/>
+              </a:spcAft>
+              <a:defRPr sz="2000" b="0">
+                <a:solidFill>
+                  <a:srgbClr val="003865"/>
+                </a:solidFill>
+                <a:latin typeface="Century Gothic"/>
+              </a:defRPr>
+            </a:pPr>
+            <a:r>
+              <a:t>Data Mart: Una subdivisión del Warehouse para un solo departamento (Ej. Finanzas).</a:t>
+            </a:r>
+          </a:p>
+        </p:txBody>
+      </p:sp>
+    </p:spTree>
+  </p:cSld>
+  <p:clrMapOvr>
+    <a:masterClrMapping/>
+  </p:clrMapOvr>
+</p:sld>
+</file>
+
+<file path=ppt/slides/slide7.xml><?xml version="1.0" encoding="utf-8"?>
+<p:sld xmlns:a="http://schemas.openxmlformats.org/drawingml/2006/main" xmlns:p="http://schemas.openxmlformats.org/presentationml/2006/main" xmlns:r="http://schemas.openxmlformats.org/officeDocument/2006/relationships">
+  <p:cSld>
+    <p:bg>
+      <p:bgPr>
+        <a:solidFill>
+          <a:srgbClr val="F0F0F0"/>
+        </a:solidFill>
+        <a:effectLst/>
+      </p:bgPr>
+    </p:bg>
+    <p:spTree>
+      <p:nvGrpSpPr>
+        <p:cNvPr id="1" name=""/>
+        <p:cNvGrpSpPr/>
+        <p:nvPr/>
+      </p:nvGrpSpPr>
+      <p:grpSpPr/>
+      <p:sp>
+        <p:nvSpPr>
+          <p:cNvPr id="2" name="TextBox 1"/>
+          <p:cNvSpPr txBox="1"/>
+          <p:nvPr/>
+        </p:nvSpPr>
+        <p:spPr>
+          <a:xfrm>
+            <a:off x="457200" y="182880"/>
+            <a:ext cx="11274552" cy="914400"/>
+          </a:xfrm>
+          <a:prstGeom prst="rect">
+            <a:avLst/>
+          </a:prstGeom>
+          <a:noFill/>
+        </p:spPr>
+        <p:txBody>
+          <a:bodyPr wrap="none">
+            <a:spAutoFit/>
+          </a:bodyPr>
+          <a:lstStyle/>
+          <a:p>
+            <a:pPr algn="l"/>
+            <a:r>
+              <a:rPr sz="4000" b="1">
+                <a:solidFill>
+                  <a:srgbClr val="003865"/>
+                </a:solidFill>
+                <a:latin typeface="Century Gothic"/>
+              </a:rPr>
+              <a:t>Storytelling con Datos</a:t>
+            </a:r>
+          </a:p>
+        </p:txBody>
+      </p:sp>
+      <p:sp>
+        <p:nvSpPr>
+          <p:cNvPr id="3" name="Rectangle 2"/>
+          <p:cNvSpPr/>
+          <p:nvPr/>
+        </p:nvSpPr>
+        <p:spPr>
+          <a:xfrm>
+            <a:off x="457200" y="1097280"/>
+            <a:ext cx="11274552" cy="45720"/>
+          </a:xfrm>
+          <a:prstGeom prst="rect">
+            <a:avLst/>
+          </a:prstGeom>
+          <a:solidFill>
+            <a:srgbClr val="E85C0B"/>
+          </a:solidFill>
+          <a:ln>
+            <a:solidFill>
+              <a:srgbClr val="E85C0B"/>
+            </a:solidFill>
+          </a:ln>
+        </p:spPr>
+        <p:style>
+          <a:lnRef idx="1">
+            <a:schemeClr val="accent1"/>
+          </a:lnRef>
+          <a:fillRef idx="3">
+            <a:schemeClr val="accent1"/>
+          </a:fillRef>
+          <a:effectRef idx="2">
+            <a:schemeClr val="accent1"/>
+          </a:effectRef>
+          <a:fontRef idx="minor">
+            <a:schemeClr val="lt1"/>
+          </a:fontRef>
+        </p:style>
+        <p:txBody>
+          <a:bodyPr rtlCol="0" anchor="ctr"/>
+          <a:lstStyle/>
+          <a:p>
+            <a:pPr algn="ctr"/>
+          </a:p>
+        </p:txBody>
+      </p:sp>
+      <p:sp>
+        <p:nvSpPr>
+          <p:cNvPr id="4" name="TextBox 3"/>
+          <p:cNvSpPr txBox="1"/>
+          <p:nvPr/>
+        </p:nvSpPr>
+        <p:spPr>
+          <a:xfrm>
+            <a:off x="457200" y="1280160"/>
+            <a:ext cx="11274552" cy="5303520"/>
+          </a:xfrm>
+          <a:prstGeom prst="rect">
+            <a:avLst/>
+          </a:prstGeom>
+          <a:noFill/>
+        </p:spPr>
+        <p:txBody>
+          <a:bodyPr wrap="square">
+            <a:spAutoFit/>
+          </a:bodyPr>
+          <a:lstStyle/>
+          <a:p/>
+          <a:p>
+            <a:pPr>
+              <a:spcAft>
+                <a:spcPts val="1000"/>
+              </a:spcAft>
+              <a:defRPr sz="2800" b="1">
                 <a:solidFill>
                   <a:srgbClr val="E85C0B"/>
                 </a:solidFill>
@@ -4520,12 +4850,31 @@
               </a:defRPr>
             </a:pPr>
             <a:r>
-              <a:t>Análisis Crítico de Dashboards</a:t>
+              <a:t>Principios de Diseño Visual (Knaflic, 2015):</a:t>
+            </a:r>
+          </a:p>
+          <a:p>
+            <a:pPr>
+              <a:spcAft>
+                <a:spcPts val="1000"/>
+              </a:spcAft>
+              <a:defRPr sz="2400" b="1">
+                <a:solidFill>
+                  <a:srgbClr val="003865"/>
+                </a:solidFill>
+                <a:latin typeface="Century Gothic"/>
+              </a:defRPr>
+            </a:pPr>
+            <a:r>
+              <a:t>1. Eliminar el desorden (Declutter):</a:t>
             </a:r>
           </a:p>
           <a:p>
             <a:pPr lvl="1">
-              <a:defRPr sz="2600" b="0">
+              <a:spcAft>
+                <a:spcPts val="1000"/>
+              </a:spcAft>
+              <a:defRPr sz="2000" b="0">
                 <a:solidFill>
                   <a:srgbClr val="003865"/>
                 </a:solidFill>
@@ -4533,12 +4882,31 @@
               </a:defRPr>
             </a:pPr>
             <a:r>
-              <a:t>1. Busquen en internet 2 Dashboards de Ventas (Uno saturado y uno limpio).</a:t>
+              <a:t>Elimina bordes de gráficos, gridlines de fondo, colores innecesarios y sombras.</a:t>
+            </a:r>
+          </a:p>
+          <a:p>
+            <a:pPr>
+              <a:spcAft>
+                <a:spcPts val="1000"/>
+              </a:spcAft>
+              <a:defRPr sz="2400" b="1">
+                <a:solidFill>
+                  <a:srgbClr val="003865"/>
+                </a:solidFill>
+                <a:latin typeface="Century Gothic"/>
+              </a:defRPr>
+            </a:pPr>
+            <a:r>
+              <a:t>2. Dirigir la Atención (Principios Gestalt):</a:t>
             </a:r>
           </a:p>
           <a:p>
             <a:pPr lvl="1">
-              <a:defRPr sz="2600" b="0">
+              <a:spcAft>
+                <a:spcPts val="1000"/>
+              </a:spcAft>
+              <a:defRPr sz="2000" b="0">
                 <a:solidFill>
                   <a:srgbClr val="003865"/>
                 </a:solidFill>
@@ -4546,12 +4914,355 @@
               </a:defRPr>
             </a:pPr>
             <a:r>
+              <a:t>Usa colores vibrantes (naranja) SOLO para los datos clave. El resto en tonos neutros (gris/azul).</a:t>
+            </a:r>
+          </a:p>
+          <a:p>
+            <a:pPr>
+              <a:spcAft>
+                <a:spcPts val="1000"/>
+              </a:spcAft>
+              <a:defRPr sz="2400" b="1">
+                <a:solidFill>
+                  <a:srgbClr val="003865"/>
+                </a:solidFill>
+                <a:latin typeface="Century Gothic"/>
+              </a:defRPr>
+            </a:pPr>
+            <a:r>
+              <a:t>3. Evitar el 3D a toda costa:</a:t>
+            </a:r>
+          </a:p>
+          <a:p>
+            <a:pPr lvl="1">
+              <a:spcAft>
+                <a:spcPts val="1000"/>
+              </a:spcAft>
+              <a:defRPr sz="2000" b="0">
+                <a:solidFill>
+                  <a:srgbClr val="003865"/>
+                </a:solidFill>
+                <a:latin typeface="Century Gothic"/>
+              </a:defRPr>
+            </a:pPr>
+            <a:r>
+              <a:t>Los gráficos 3D (especialmente Pie Charts) distorsionan la percepción geométrica del cerebro.</a:t>
+            </a:r>
+          </a:p>
+        </p:txBody>
+      </p:sp>
+    </p:spTree>
+  </p:cSld>
+  <p:clrMapOvr>
+    <a:masterClrMapping/>
+  </p:clrMapOvr>
+</p:sld>
+</file>
+
+<file path=ppt/slides/slide8.xml><?xml version="1.0" encoding="utf-8"?>
+<p:sld xmlns:a="http://schemas.openxmlformats.org/drawingml/2006/main" xmlns:p="http://schemas.openxmlformats.org/presentationml/2006/main" xmlns:r="http://schemas.openxmlformats.org/officeDocument/2006/relationships">
+  <p:cSld>
+    <p:bg>
+      <p:bgPr>
+        <a:solidFill>
+          <a:srgbClr val="F0F0F0"/>
+        </a:solidFill>
+        <a:effectLst/>
+      </p:bgPr>
+    </p:bg>
+    <p:spTree>
+      <p:nvGrpSpPr>
+        <p:cNvPr id="1" name=""/>
+        <p:cNvGrpSpPr/>
+        <p:nvPr/>
+      </p:nvGrpSpPr>
+      <p:grpSpPr/>
+      <p:sp>
+        <p:nvSpPr>
+          <p:cNvPr id="2" name="TextBox 1"/>
+          <p:cNvSpPr txBox="1"/>
+          <p:nvPr/>
+        </p:nvSpPr>
+        <p:spPr>
+          <a:xfrm>
+            <a:off x="457200" y="182880"/>
+            <a:ext cx="11274552" cy="914400"/>
+          </a:xfrm>
+          <a:prstGeom prst="rect">
+            <a:avLst/>
+          </a:prstGeom>
+          <a:noFill/>
+        </p:spPr>
+        <p:txBody>
+          <a:bodyPr wrap="none">
+            <a:spAutoFit/>
+          </a:bodyPr>
+          <a:lstStyle/>
+          <a:p>
+            <a:pPr algn="l"/>
+            <a:r>
+              <a:rPr sz="3500" b="1">
+                <a:solidFill>
+                  <a:srgbClr val="003865"/>
+                </a:solidFill>
+                <a:latin typeface="Century Gothic"/>
+              </a:rPr>
+              <a:t>Simulación: Dashboard de Alto Impacto (Knaflic)</a:t>
+            </a:r>
+          </a:p>
+        </p:txBody>
+      </p:sp>
+      <p:sp>
+        <p:nvSpPr>
+          <p:cNvPr id="3" name="Rectangle 2"/>
+          <p:cNvSpPr/>
+          <p:nvPr/>
+        </p:nvSpPr>
+        <p:spPr>
+          <a:xfrm>
+            <a:off x="457200" y="1097280"/>
+            <a:ext cx="11274552" cy="45720"/>
+          </a:xfrm>
+          <a:prstGeom prst="rect">
+            <a:avLst/>
+          </a:prstGeom>
+          <a:solidFill>
+            <a:srgbClr val="E85C0B"/>
+          </a:solidFill>
+          <a:ln>
+            <a:solidFill>
+              <a:srgbClr val="E85C0B"/>
+            </a:solidFill>
+          </a:ln>
+        </p:spPr>
+        <p:style>
+          <a:lnRef idx="1">
+            <a:schemeClr val="accent1"/>
+          </a:lnRef>
+          <a:fillRef idx="3">
+            <a:schemeClr val="accent1"/>
+          </a:fillRef>
+          <a:effectRef idx="2">
+            <a:schemeClr val="accent1"/>
+          </a:effectRef>
+          <a:fontRef idx="minor">
+            <a:schemeClr val="lt1"/>
+          </a:fontRef>
+        </p:style>
+        <p:txBody>
+          <a:bodyPr rtlCol="0" anchor="ctr"/>
+          <a:lstStyle/>
+          <a:p>
+            <a:pPr algn="ctr"/>
+          </a:p>
+        </p:txBody>
+      </p:sp>
+      <p:pic>
+        <p:nvPicPr>
+          <p:cNvPr id="4" name="Picture 3" descr="dashboard_mockup.png"/>
+          <p:cNvPicPr>
+            <a:picLocks noChangeAspect="1"/>
+          </p:cNvPicPr>
+          <p:nvPr/>
+        </p:nvPicPr>
+        <p:blipFill>
+          <a:blip r:embed="rId2"/>
+          <a:stretch>
+            <a:fillRect/>
+          </a:stretch>
+        </p:blipFill>
+        <p:spPr>
+          <a:xfrm>
+            <a:off x="1828800" y="1371600"/>
+            <a:ext cx="8503920" cy="8503920"/>
+          </a:xfrm>
+          <a:prstGeom prst="rect">
+            <a:avLst/>
+          </a:prstGeom>
+        </p:spPr>
+      </p:pic>
+    </p:spTree>
+  </p:cSld>
+  <p:clrMapOvr>
+    <a:masterClrMapping/>
+  </p:clrMapOvr>
+</p:sld>
+</file>
+
+<file path=ppt/slides/slide9.xml><?xml version="1.0" encoding="utf-8"?>
+<p:sld xmlns:a="http://schemas.openxmlformats.org/drawingml/2006/main" xmlns:p="http://schemas.openxmlformats.org/presentationml/2006/main" xmlns:r="http://schemas.openxmlformats.org/officeDocument/2006/relationships">
+  <p:cSld>
+    <p:bg>
+      <p:bgPr>
+        <a:solidFill>
+          <a:srgbClr val="F0F0F0"/>
+        </a:solidFill>
+        <a:effectLst/>
+      </p:bgPr>
+    </p:bg>
+    <p:spTree>
+      <p:nvGrpSpPr>
+        <p:cNvPr id="1" name=""/>
+        <p:cNvGrpSpPr/>
+        <p:nvPr/>
+      </p:nvGrpSpPr>
+      <p:grpSpPr/>
+      <p:sp>
+        <p:nvSpPr>
+          <p:cNvPr id="2" name="TextBox 1"/>
+          <p:cNvSpPr txBox="1"/>
+          <p:nvPr/>
+        </p:nvSpPr>
+        <p:spPr>
+          <a:xfrm>
+            <a:off x="457200" y="182880"/>
+            <a:ext cx="11274552" cy="914400"/>
+          </a:xfrm>
+          <a:prstGeom prst="rect">
+            <a:avLst/>
+          </a:prstGeom>
+          <a:noFill/>
+        </p:spPr>
+        <p:txBody>
+          <a:bodyPr wrap="none">
+            <a:spAutoFit/>
+          </a:bodyPr>
+          <a:lstStyle/>
+          <a:p>
+            <a:pPr algn="l"/>
+            <a:r>
+              <a:rPr sz="4000" b="1">
+                <a:solidFill>
+                  <a:srgbClr val="003865"/>
+                </a:solidFill>
+                <a:latin typeface="Century Gothic"/>
+              </a:rPr>
+              <a:t>Taller: Pair Programming</a:t>
+            </a:r>
+          </a:p>
+        </p:txBody>
+      </p:sp>
+      <p:sp>
+        <p:nvSpPr>
+          <p:cNvPr id="3" name="Rectangle 2"/>
+          <p:cNvSpPr/>
+          <p:nvPr/>
+        </p:nvSpPr>
+        <p:spPr>
+          <a:xfrm>
+            <a:off x="457200" y="1097280"/>
+            <a:ext cx="11274552" cy="45720"/>
+          </a:xfrm>
+          <a:prstGeom prst="rect">
+            <a:avLst/>
+          </a:prstGeom>
+          <a:solidFill>
+            <a:srgbClr val="E85C0B"/>
+          </a:solidFill>
+          <a:ln>
+            <a:solidFill>
+              <a:srgbClr val="E85C0B"/>
+            </a:solidFill>
+          </a:ln>
+        </p:spPr>
+        <p:style>
+          <a:lnRef idx="1">
+            <a:schemeClr val="accent1"/>
+          </a:lnRef>
+          <a:fillRef idx="3">
+            <a:schemeClr val="accent1"/>
+          </a:fillRef>
+          <a:effectRef idx="2">
+            <a:schemeClr val="accent1"/>
+          </a:effectRef>
+          <a:fontRef idx="minor">
+            <a:schemeClr val="lt1"/>
+          </a:fontRef>
+        </p:style>
+        <p:txBody>
+          <a:bodyPr rtlCol="0" anchor="ctr"/>
+          <a:lstStyle/>
+          <a:p>
+            <a:pPr algn="ctr"/>
+          </a:p>
+        </p:txBody>
+      </p:sp>
+      <p:sp>
+        <p:nvSpPr>
+          <p:cNvPr id="4" name="TextBox 3"/>
+          <p:cNvSpPr txBox="1"/>
+          <p:nvPr/>
+        </p:nvSpPr>
+        <p:spPr>
+          <a:xfrm>
+            <a:off x="457200" y="1280160"/>
+            <a:ext cx="11274552" cy="5303520"/>
+          </a:xfrm>
+          <a:prstGeom prst="rect">
+            <a:avLst/>
+          </a:prstGeom>
+          <a:noFill/>
+        </p:spPr>
+        <p:txBody>
+          <a:bodyPr wrap="square">
+            <a:spAutoFit/>
+          </a:bodyPr>
+          <a:lstStyle/>
+          <a:p/>
+          <a:p>
+            <a:pPr>
+              <a:spcAft>
+                <a:spcPts val="1000"/>
+              </a:spcAft>
+              <a:defRPr sz="3000" b="1">
+                <a:solidFill>
+                  <a:srgbClr val="E85C0B"/>
+                </a:solidFill>
+                <a:latin typeface="Century Gothic"/>
+              </a:defRPr>
+            </a:pPr>
+            <a:r>
+              <a:t>Análisis Crítico de Dashboards en el Mundo Real</a:t>
+            </a:r>
+          </a:p>
+          <a:p>
+            <a:pPr lvl="1">
+              <a:spcAft>
+                <a:spcPts val="1000"/>
+              </a:spcAft>
+              <a:defRPr sz="2400" b="0">
+                <a:solidFill>
+                  <a:srgbClr val="003865"/>
+                </a:solidFill>
+                <a:latin typeface="Century Gothic"/>
+              </a:defRPr>
+            </a:pPr>
+            <a:r>
+              <a:t>1. En parejas, busquen en internet 2 Dashboards (Uno saturado/malo y uno limpio/bueno).</a:t>
+            </a:r>
+          </a:p>
+          <a:p>
+            <a:pPr lvl="1">
+              <a:spcAft>
+                <a:spcPts val="1000"/>
+              </a:spcAft>
+              <a:defRPr sz="2400" b="0">
+                <a:solidFill>
+                  <a:srgbClr val="003865"/>
+                </a:solidFill>
+                <a:latin typeface="Century Gothic"/>
+              </a:defRPr>
+            </a:pPr>
+            <a:r>
               <a:t>2. Analicen qué principios de Gestalt y 'Decluttering' se violan en el malo.</a:t>
             </a:r>
           </a:p>
           <a:p>
             <a:pPr lvl="1">
-              <a:defRPr sz="2600" b="0">
+              <a:spcAft>
+                <a:spcPts val="1000"/>
+              </a:spcAft>
+              <a:defRPr sz="2400" b="0">
                 <a:solidFill>
                   <a:srgbClr val="003865"/>
                 </a:solidFill>
@@ -4559,12 +5270,15 @@
               </a:defRPr>
             </a:pPr>
             <a:r>
-              <a:t>3. Redacten un resumen en formato Markdown y súbanlo a GitHub.</a:t>
+              <a:t>3. Analicen la jerarquía visual del Dashboard bueno.</a:t>
             </a:r>
           </a:p>
           <a:p>
             <a:pPr lvl="1">
-              <a:defRPr sz="2600" b="1">
+              <a:spcAft>
+                <a:spcPts val="1000"/>
+              </a:spcAft>
+              <a:defRPr sz="2400" b="0">
                 <a:solidFill>
                   <a:srgbClr val="003865"/>
                 </a:solidFill>
@@ -4572,7 +5286,23 @@
               </a:defRPr>
             </a:pPr>
             <a:r>
-              <a:t>Usen LLMNotebook como asistente crítico para esta evaluación.</a:t>
+              <a:t>4. Redacten un resumen en formato Markdown y súbanlo a su repositorio de GitHub.</a:t>
+            </a:r>
+          </a:p>
+          <a:p>
+            <a:pPr lvl="1">
+              <a:spcAft>
+                <a:spcPts val="1000"/>
+              </a:spcAft>
+              <a:defRPr sz="2400" b="1">
+                <a:solidFill>
+                  <a:srgbClr val="003865"/>
+                </a:solidFill>
+                <a:latin typeface="Century Gothic"/>
+              </a:defRPr>
+            </a:pPr>
+            <a:r>
+              <a:t>Nota: Usen LLMNotebook/ChatGPT como asistente crítico para la revisión.</a:t>
             </a:r>
           </a:p>
         </p:txBody>

</xml_diff>

<commit_message>
feat: rediseño estructural interactivo HTML/PPT y aplicacion de layouts variados responsivos
</commit_message>
<xml_diff>
--- a/Semanas/Semana_1/diapositivas_semana_1.pptx
+++ b/Semanas/Semana_1/diapositivas_semana_1.pptx
@@ -13,9 +13,6 @@
     <p:sldId id="261" r:id="rId12"/>
     <p:sldId id="262" r:id="rId13"/>
     <p:sldId id="263" r:id="rId14"/>
-    <p:sldId id="264" r:id="rId15"/>
-    <p:sldId id="265" r:id="rId16"/>
-    <p:sldId id="266" r:id="rId17"/>
   </p:sldIdLst>
   <p:sldSz cx="12191695" cy="6858000" type="screen4x3"/>
   <p:notesSz cx="6858000" cy="9144000"/>
@@ -3165,19 +3162,19 @@
           <a:p>
             <a:pPr algn="ctr"/>
             <a:r>
-              <a:rPr sz="3000" b="0">
+              <a:rPr sz="2800" b="0">
                 <a:solidFill>
                   <a:srgbClr val="FFFFFF"/>
                 </a:solidFill>
                 <a:latin typeface="Century Gothic"/>
               </a:rPr>
-              <a:t>Clase 1: Introducción, Evolución y Conceptos Básicos</a:t>
+              <a:t>Clase 1: Evolución, Ecosistema y Diseño</a:t>
             </a:r>
           </a:p>
           <a:p>
             <a:pPr algn="ctr"/>
             <a:r>
-              <a:rPr sz="3000" b="0">
+              <a:rPr sz="2800" b="0">
                 <a:solidFill>
                   <a:srgbClr val="FFFFFF"/>
                 </a:solidFill>
@@ -3196,7 +3193,7 @@
 </p:sld>
 </file>
 
-<file path=ppt/slides/slide10.xml><?xml version="1.0" encoding="utf-8"?>
+<file path=ppt/slides/slide2.xml><?xml version="1.0" encoding="utf-8"?>
 <p:sld xmlns:a="http://schemas.openxmlformats.org/drawingml/2006/main" xmlns:p="http://schemas.openxmlformats.org/presentationml/2006/main" xmlns:r="http://schemas.openxmlformats.org/officeDocument/2006/relationships">
   <p:cSld>
     <p:bg>
@@ -3238,13 +3235,13 @@
           <a:p>
             <a:pPr algn="l"/>
             <a:r>
-              <a:rPr sz="4000" b="1">
+              <a:rPr sz="3600" b="1">
                 <a:solidFill>
                   <a:srgbClr val="003865"/>
                 </a:solidFill>
                 <a:latin typeface="Century Gothic"/>
               </a:rPr>
-              <a:t>Conclusiones de la Sesión</a:t>
+              <a:t>Hoja de Ruta</a:t>
             </a:r>
           </a:p>
         </p:txBody>
@@ -3257,7 +3254,7 @@
         </p:nvSpPr>
         <p:spPr>
           <a:xfrm>
-            <a:off x="457200" y="1097280"/>
+            <a:off x="457200" y="1005840"/>
             <a:ext cx="11274552" cy="45720"/>
           </a:xfrm>
           <a:prstGeom prst="rect">
@@ -3302,7 +3299,7 @@
         </p:nvSpPr>
         <p:spPr>
           <a:xfrm>
-            <a:off x="457200" y="1280160"/>
+            <a:off x="457200" y="1188720"/>
             <a:ext cx="11274552" cy="5303520"/>
           </a:xfrm>
           <a:prstGeom prst="rect">
@@ -3319,65 +3316,97 @@
           <a:p>
             <a:pPr>
               <a:spcAft>
-                <a:spcPts val="1000"/>
+                <a:spcPts val="800"/>
               </a:spcAft>
-              <a:defRPr sz="2800" b="1">
-                <a:solidFill>
-                  <a:srgbClr val="003865"/>
+              <a:defRPr sz="2600" b="1">
+                <a:solidFill>
+                  <a:srgbClr val="E85C0B"/>
                 </a:solidFill>
                 <a:latin typeface="Century Gothic"/>
               </a:defRPr>
             </a:pPr>
             <a:r>
-              <a:t>El BI no es solo tecnología, es una herramienta estratégica:</a:t>
-            </a:r>
-          </a:p>
-          <a:p>
-            <a:pPr lvl="1">
+              <a:t>1. Acuerdos y Reglas de Clase</a:t>
+            </a:r>
+          </a:p>
+          <a:p>
+            <a:pPr>
               <a:spcAft>
-                <a:spcPts val="1000"/>
+                <a:spcPts val="800"/>
               </a:spcAft>
-              <a:defRPr sz="2400" b="0">
-                <a:solidFill>
-                  <a:srgbClr val="003865"/>
+              <a:defRPr sz="2600" b="1">
+                <a:solidFill>
+                  <a:srgbClr val="E85C0B"/>
                 </a:solidFill>
                 <a:latin typeface="Century Gothic"/>
               </a:defRPr>
             </a:pPr>
             <a:r>
-              <a:t>El verdadero valor del BI está en pasar de los datos descriptivos (pasado) a las decisiones prescriptivas (acciones).</a:t>
+              <a:t>2. Estrategia EMI (Warm-up en Inglés)</a:t>
             </a:r>
           </a:p>
           <a:p>
             <a:pPr>
               <a:spcAft>
-                <a:spcPts val="1000"/>
+                <a:spcPts val="800"/>
               </a:spcAft>
-              <a:defRPr sz="2800" b="1">
-                <a:solidFill>
-                  <a:srgbClr val="003865"/>
+              <a:defRPr sz="2600" b="1">
+                <a:solidFill>
+                  <a:srgbClr val="E85C0B"/>
                 </a:solidFill>
                 <a:latin typeface="Century Gothic"/>
               </a:defRPr>
             </a:pPr>
             <a:r>
-              <a:t>El diseño visual importa tanto como el modelo de datos:</a:t>
-            </a:r>
-          </a:p>
-          <a:p>
-            <a:pPr lvl="1">
+              <a:t>3. Ecosistema de Inteligencia de Negocios</a:t>
+            </a:r>
+          </a:p>
+          <a:p>
+            <a:pPr>
               <a:spcAft>
-                <a:spcPts val="1000"/>
+                <a:spcPts val="800"/>
               </a:spcAft>
-              <a:defRPr sz="2400" b="0">
-                <a:solidFill>
-                  <a:srgbClr val="003865"/>
+              <a:defRPr sz="2600" b="1">
+                <a:solidFill>
+                  <a:srgbClr val="E85C0B"/>
                 </a:solidFill>
                 <a:latin typeface="Century Gothic"/>
               </a:defRPr>
             </a:pPr>
             <a:r>
-              <a:t>Un modelo perfecto (Data Warehouse robusto) fracasa si el Dashboard es ilegible (Exceso de Clutter).</a:t>
+              <a:t>4. Storytelling with Data (Knaflic)</a:t>
+            </a:r>
+          </a:p>
+          <a:p>
+            <a:pPr>
+              <a:spcAft>
+                <a:spcPts val="800"/>
+              </a:spcAft>
+              <a:defRPr sz="2600" b="1">
+                <a:solidFill>
+                  <a:srgbClr val="E85C0B"/>
+                </a:solidFill>
+                <a:latin typeface="Century Gothic"/>
+              </a:defRPr>
+            </a:pPr>
+            <a:r>
+              <a:t>5. Taller Práctico: Pair Programming</a:t>
+            </a:r>
+          </a:p>
+          <a:p>
+            <a:pPr>
+              <a:spcAft>
+                <a:spcPts val="800"/>
+              </a:spcAft>
+              <a:defRPr sz="2600" b="1">
+                <a:solidFill>
+                  <a:srgbClr val="E85C0B"/>
+                </a:solidFill>
+                <a:latin typeface="Century Gothic"/>
+              </a:defRPr>
+            </a:pPr>
+            <a:r>
+              <a:t>6. Conclusiones y Bibliografía</a:t>
             </a:r>
           </a:p>
         </p:txBody>
@@ -3390,7 +3419,7 @@
 </p:sld>
 </file>
 
-<file path=ppt/slides/slide11.xml><?xml version="1.0" encoding="utf-8"?>
+<file path=ppt/slides/slide3.xml><?xml version="1.0" encoding="utf-8"?>
 <p:sld xmlns:a="http://schemas.openxmlformats.org/drawingml/2006/main" xmlns:p="http://schemas.openxmlformats.org/presentationml/2006/main" xmlns:r="http://schemas.openxmlformats.org/officeDocument/2006/relationships">
   <p:cSld>
     <p:bg>
@@ -3432,13 +3461,13 @@
           <a:p>
             <a:pPr algn="l"/>
             <a:r>
-              <a:rPr sz="4000" b="1">
+              <a:rPr sz="3600" b="1">
                 <a:solidFill>
                   <a:srgbClr val="003865"/>
                 </a:solidFill>
                 <a:latin typeface="Century Gothic"/>
               </a:rPr>
-              <a:t>Bibliografía y Referencias</a:t>
+              <a:t>Evolución del BI (Línea de Tiempo)</a:t>
             </a:r>
           </a:p>
         </p:txBody>
@@ -3451,7 +3480,7 @@
         </p:nvSpPr>
         <p:spPr>
           <a:xfrm>
-            <a:off x="457200" y="1097280"/>
+            <a:off x="457200" y="1005840"/>
             <a:ext cx="11274552" cy="45720"/>
           </a:xfrm>
           <a:prstGeom prst="rect">
@@ -3496,7 +3525,7 @@
         </p:nvSpPr>
         <p:spPr>
           <a:xfrm>
-            <a:off x="457200" y="1280160"/>
+            <a:off x="457200" y="1188720"/>
             <a:ext cx="11274552" cy="5303520"/>
           </a:xfrm>
           <a:prstGeom prst="rect">
@@ -3513,25 +3542,25 @@
           <a:p>
             <a:pPr>
               <a:spcAft>
-                <a:spcPts val="1000"/>
+                <a:spcPts val="800"/>
               </a:spcAft>
-              <a:defRPr sz="2800" b="1">
-                <a:solidFill>
-                  <a:srgbClr val="E85C0B"/>
+              <a:defRPr sz="2200" b="1">
+                <a:solidFill>
+                  <a:srgbClr val="003865"/>
                 </a:solidFill>
                 <a:latin typeface="Century Gothic"/>
               </a:defRPr>
             </a:pPr>
             <a:r>
-              <a:t>Lecturas Obligatorias:</a:t>
-            </a:r>
-          </a:p>
-          <a:p>
-            <a:pPr lvl="1">
+              <a:t>1980s: Sistemas DSS (Decision Support Systems). Reportes estáticos por IT.</a:t>
+            </a:r>
+          </a:p>
+          <a:p>
+            <a:pPr>
               <a:spcAft>
-                <a:spcPts val="1000"/>
+                <a:spcPts val="800"/>
               </a:spcAft>
-              <a:defRPr sz="2200" b="0">
+              <a:defRPr sz="2200" b="1">
                 <a:solidFill>
                   <a:srgbClr val="003865"/>
                 </a:solidFill>
@@ -3539,15 +3568,15 @@
               </a:defRPr>
             </a:pPr>
             <a:r>
-              <a:t>1. Sharda, R., Delen, D., &amp; Turban, E. (2020). Business Intelligence, Analytics, and Data Science: A Managerial Perspective (4th Edition). Pearson.</a:t>
-            </a:r>
-          </a:p>
-          <a:p>
-            <a:pPr lvl="1">
+              <a:t>1990s: Data Warehousing. Nace OLAP y la Minería de Datos.</a:t>
+            </a:r>
+          </a:p>
+          <a:p>
+            <a:pPr>
               <a:spcAft>
-                <a:spcPts val="1000"/>
+                <a:spcPts val="800"/>
               </a:spcAft>
-              <a:defRPr sz="2200" b="0">
+              <a:defRPr sz="2200" b="1">
                 <a:solidFill>
                   <a:srgbClr val="003865"/>
                 </a:solidFill>
@@ -3555,16 +3584,15 @@
               </a:defRPr>
             </a:pPr>
             <a:r>
-              <a:t>2. Knaflic, C. N. (2015). Storytelling with Data: A Data Visualization Guide for Business Professionals. Wiley.</a:t>
-            </a:r>
-          </a:p>
-          <a:p>
-            <a:br/>
+              <a:t>2000s: BI Tradicional. Dashboards pesados a nivel corporativo.</a:t>
+            </a:r>
+          </a:p>
+          <a:p>
             <a:pPr>
               <a:spcAft>
-                <a:spcPts val="1000"/>
+                <a:spcPts val="800"/>
               </a:spcAft>
-              <a:defRPr sz="2800" b="1">
+              <a:defRPr sz="2200" b="1">
                 <a:solidFill>
                   <a:srgbClr val="E85C0B"/>
                 </a:solidFill>
@@ -3572,23 +3600,23 @@
               </a:defRPr>
             </a:pPr>
             <a:r>
-              <a:t>Recursos Adicionales:</a:t>
-            </a:r>
-          </a:p>
-          <a:p>
-            <a:pPr lvl="1">
+              <a:t>2010s: Self-Service BI (Power BI). Democratización del dato.</a:t>
+            </a:r>
+          </a:p>
+          <a:p>
+            <a:pPr>
               <a:spcAft>
-                <a:spcPts val="1000"/>
+                <a:spcPts val="800"/>
               </a:spcAft>
-              <a:defRPr sz="2200" b="0">
-                <a:solidFill>
-                  <a:srgbClr val="003865"/>
+              <a:defRPr sz="2200" b="1">
+                <a:solidFill>
+                  <a:srgbClr val="E85C0B"/>
                 </a:solidFill>
                 <a:latin typeface="Century Gothic"/>
               </a:defRPr>
             </a:pPr>
             <a:r>
-              <a:t>Repositorio del curso: https://github.com/dudbil/Inteligencia-de-negocios-UNAB</a:t>
+              <a:t>2020s: Augmented BI. IA Generativa integrada.</a:t>
             </a:r>
           </a:p>
         </p:txBody>
@@ -3601,7 +3629,7 @@
 </p:sld>
 </file>
 
-<file path=ppt/slides/slide2.xml><?xml version="1.0" encoding="utf-8"?>
+<file path=ppt/slides/slide4.xml><?xml version="1.0" encoding="utf-8"?>
 <p:sld xmlns:a="http://schemas.openxmlformats.org/drawingml/2006/main" xmlns:p="http://schemas.openxmlformats.org/presentationml/2006/main" xmlns:r="http://schemas.openxmlformats.org/officeDocument/2006/relationships">
   <p:cSld>
     <p:bg>
@@ -3643,13 +3671,303 @@
           <a:p>
             <a:pPr algn="l"/>
             <a:r>
-              <a:rPr sz="4000" b="1">
+              <a:rPr sz="3600" b="1">
                 <a:solidFill>
                   <a:srgbClr val="003865"/>
                 </a:solidFill>
                 <a:latin typeface="Century Gothic"/>
               </a:rPr>
-              <a:t>Agenda de la Sesión</a:t>
+              <a:t>Arquitectura Base (ETL y OLAP)</a:t>
+            </a:r>
+          </a:p>
+        </p:txBody>
+      </p:sp>
+      <p:sp>
+        <p:nvSpPr>
+          <p:cNvPr id="3" name="TextBox 2"/>
+          <p:cNvSpPr txBox="1"/>
+          <p:nvPr/>
+        </p:nvSpPr>
+        <p:spPr>
+          <a:xfrm>
+            <a:off x="457200" y="1188720"/>
+            <a:ext cx="5486400" cy="5303520"/>
+          </a:xfrm>
+          <a:prstGeom prst="rect">
+            <a:avLst/>
+          </a:prstGeom>
+          <a:noFill/>
+        </p:spPr>
+        <p:txBody>
+          <a:bodyPr wrap="square">
+            <a:spAutoFit/>
+          </a:bodyPr>
+          <a:lstStyle/>
+          <a:p/>
+          <a:p>
+            <a:pPr>
+              <a:spcAft>
+                <a:spcPts val="800"/>
+              </a:spcAft>
+              <a:defRPr sz="2600" b="1">
+                <a:solidFill>
+                  <a:srgbClr val="003865"/>
+                </a:solidFill>
+                <a:latin typeface="Century Gothic"/>
+              </a:defRPr>
+            </a:pPr>
+            <a:r>
+              <a:t>Extracción y Transformación:</a:t>
+            </a:r>
+          </a:p>
+          <a:p>
+            <a:pPr lvl="1">
+              <a:spcAft>
+                <a:spcPts val="800"/>
+              </a:spcAft>
+              <a:defRPr sz="2000" b="0">
+                <a:solidFill>
+                  <a:srgbClr val="003865"/>
+                </a:solidFill>
+                <a:latin typeface="Century Gothic"/>
+              </a:defRPr>
+            </a:pPr>
+            <a:r>
+              <a:t>El 80% del tiempo de un analista se va en limpiar datos (ETL).</a:t>
+            </a:r>
+          </a:p>
+          <a:p>
+            <a:pPr lvl="1">
+              <a:spcAft>
+                <a:spcPts val="800"/>
+              </a:spcAft>
+              <a:defRPr sz="2000" b="0">
+                <a:solidFill>
+                  <a:srgbClr val="003865"/>
+                </a:solidFill>
+                <a:latin typeface="Century Gothic"/>
+              </a:defRPr>
+            </a:pPr>
+            <a:r>
+              <a:t>Sistemas OLTP son para registrar la venta en caja, no para sacar métricas de 5 años.</a:t>
+            </a:r>
+          </a:p>
+        </p:txBody>
+      </p:sp>
+      <p:sp>
+        <p:nvSpPr>
+          <p:cNvPr id="4" name="TextBox 3"/>
+          <p:cNvSpPr txBox="1"/>
+          <p:nvPr/>
+        </p:nvSpPr>
+        <p:spPr>
+          <a:xfrm>
+            <a:off x="6217920" y="1188720"/>
+            <a:ext cx="5486400" cy="5303520"/>
+          </a:xfrm>
+          <a:prstGeom prst="rect">
+            <a:avLst/>
+          </a:prstGeom>
+          <a:noFill/>
+        </p:spPr>
+        <p:txBody>
+          <a:bodyPr wrap="square">
+            <a:spAutoFit/>
+          </a:bodyPr>
+          <a:lstStyle/>
+          <a:p/>
+          <a:p>
+            <a:pPr>
+              <a:spcAft>
+                <a:spcPts val="800"/>
+              </a:spcAft>
+              <a:defRPr sz="2600" b="1">
+                <a:solidFill>
+                  <a:srgbClr val="003865"/>
+                </a:solidFill>
+                <a:latin typeface="Century Gothic"/>
+              </a:defRPr>
+            </a:pPr>
+            <a:r>
+              <a:t>Carga y Visualización:</a:t>
+            </a:r>
+          </a:p>
+          <a:p>
+            <a:pPr lvl="1">
+              <a:spcAft>
+                <a:spcPts val="800"/>
+              </a:spcAft>
+              <a:defRPr sz="2000" b="0">
+                <a:solidFill>
+                  <a:srgbClr val="003865"/>
+                </a:solidFill>
+                <a:latin typeface="Century Gothic"/>
+              </a:defRPr>
+            </a:pPr>
+            <a:r>
+              <a:t>El Data Warehouse almacena la historia limpia (OLAP).</a:t>
+            </a:r>
+          </a:p>
+          <a:p>
+            <a:pPr lvl="1">
+              <a:spcAft>
+                <a:spcPts val="800"/>
+              </a:spcAft>
+              <a:defRPr sz="2000" b="0">
+                <a:solidFill>
+                  <a:srgbClr val="003865"/>
+                </a:solidFill>
+                <a:latin typeface="Century Gothic"/>
+              </a:defRPr>
+            </a:pPr>
+            <a:r>
+              <a:t>Los Dashboards consumen de ese Warehouse.</a:t>
+            </a:r>
+          </a:p>
+        </p:txBody>
+      </p:sp>
+    </p:spTree>
+  </p:cSld>
+  <p:clrMapOvr>
+    <a:masterClrMapping/>
+  </p:clrMapOvr>
+</p:sld>
+</file>
+
+<file path=ppt/slides/slide5.xml><?xml version="1.0" encoding="utf-8"?>
+<p:sld xmlns:a="http://schemas.openxmlformats.org/drawingml/2006/main" xmlns:p="http://schemas.openxmlformats.org/presentationml/2006/main" xmlns:r="http://schemas.openxmlformats.org/officeDocument/2006/relationships">
+  <p:cSld>
+    <p:bg>
+      <p:bgPr>
+        <a:solidFill>
+          <a:srgbClr val="003865"/>
+        </a:solidFill>
+        <a:effectLst/>
+      </p:bgPr>
+    </p:bg>
+    <p:spTree>
+      <p:nvGrpSpPr>
+        <p:cNvPr id="1" name=""/>
+        <p:cNvGrpSpPr/>
+        <p:nvPr/>
+      </p:nvGrpSpPr>
+      <p:grpSpPr/>
+      <p:sp>
+        <p:nvSpPr>
+          <p:cNvPr id="2" name="TextBox 1"/>
+          <p:cNvSpPr txBox="1"/>
+          <p:nvPr/>
+        </p:nvSpPr>
+        <p:spPr>
+          <a:xfrm>
+            <a:off x="914400" y="1828800"/>
+            <a:ext cx="10360152" cy="2743200"/>
+          </a:xfrm>
+          <a:prstGeom prst="rect">
+            <a:avLst/>
+          </a:prstGeom>
+          <a:noFill/>
+        </p:spPr>
+        <p:txBody>
+          <a:bodyPr wrap="none">
+            <a:spAutoFit/>
+          </a:bodyPr>
+          <a:lstStyle/>
+          <a:p>
+            <a:pPr algn="ctr"/>
+            <a:r>
+              <a:rPr sz="4500" b="1">
+                <a:solidFill>
+                  <a:srgbClr val="E85C0B"/>
+                </a:solidFill>
+                <a:latin typeface="Century Gothic"/>
+              </a:rPr>
+              <a:t>Storytelling with Data</a:t>
+            </a:r>
+          </a:p>
+          <a:p>
+            <a:pPr algn="ctr"/>
+            <a:r>
+              <a:rPr sz="4500" b="1">
+                <a:solidFill>
+                  <a:srgbClr val="E85C0B"/>
+                </a:solidFill>
+                <a:latin typeface="Century Gothic"/>
+              </a:rPr>
+              <a:t>No se trata de mostrar números.</a:t>
+            </a:r>
+          </a:p>
+          <a:p>
+            <a:pPr algn="ctr"/>
+            <a:r>
+              <a:rPr sz="4500" b="1">
+                <a:solidFill>
+                  <a:srgbClr val="E85C0B"/>
+                </a:solidFill>
+                <a:latin typeface="Century Gothic"/>
+              </a:rPr>
+              <a:t>Se trata de inspirar acciones.</a:t>
+            </a:r>
+          </a:p>
+        </p:txBody>
+      </p:sp>
+    </p:spTree>
+  </p:cSld>
+  <p:clrMapOvr>
+    <a:masterClrMapping/>
+  </p:clrMapOvr>
+</p:sld>
+</file>
+
+<file path=ppt/slides/slide6.xml><?xml version="1.0" encoding="utf-8"?>
+<p:sld xmlns:a="http://schemas.openxmlformats.org/drawingml/2006/main" xmlns:p="http://schemas.openxmlformats.org/presentationml/2006/main" xmlns:r="http://schemas.openxmlformats.org/officeDocument/2006/relationships">
+  <p:cSld>
+    <p:bg>
+      <p:bgPr>
+        <a:solidFill>
+          <a:srgbClr val="F0F0F0"/>
+        </a:solidFill>
+        <a:effectLst/>
+      </p:bgPr>
+    </p:bg>
+    <p:spTree>
+      <p:nvGrpSpPr>
+        <p:cNvPr id="1" name=""/>
+        <p:cNvGrpSpPr/>
+        <p:nvPr/>
+      </p:nvGrpSpPr>
+      <p:grpSpPr/>
+      <p:sp>
+        <p:nvSpPr>
+          <p:cNvPr id="2" name="TextBox 1"/>
+          <p:cNvSpPr txBox="1"/>
+          <p:nvPr/>
+        </p:nvSpPr>
+        <p:spPr>
+          <a:xfrm>
+            <a:off x="457200" y="182880"/>
+            <a:ext cx="11274552" cy="914400"/>
+          </a:xfrm>
+          <a:prstGeom prst="rect">
+            <a:avLst/>
+          </a:prstGeom>
+          <a:noFill/>
+        </p:spPr>
+        <p:txBody>
+          <a:bodyPr wrap="none">
+            <a:spAutoFit/>
+          </a:bodyPr>
+          <a:lstStyle/>
+          <a:p>
+            <a:pPr algn="l"/>
+            <a:r>
+              <a:rPr sz="3600" b="1">
+                <a:solidFill>
+                  <a:srgbClr val="003865"/>
+                </a:solidFill>
+                <a:latin typeface="Century Gothic"/>
+              </a:rPr>
+              <a:t>Pro-Tips de Diseño (Knaflic)</a:t>
             </a:r>
           </a:p>
         </p:txBody>
@@ -3662,7 +3980,7 @@
         </p:nvSpPr>
         <p:spPr>
           <a:xfrm>
-            <a:off x="457200" y="1097280"/>
+            <a:off x="457200" y="1005840"/>
             <a:ext cx="11274552" cy="45720"/>
           </a:xfrm>
           <a:prstGeom prst="rect">
@@ -3707,7 +4025,7 @@
         </p:nvSpPr>
         <p:spPr>
           <a:xfrm>
-            <a:off x="457200" y="1280160"/>
+            <a:off x="457200" y="1188720"/>
             <a:ext cx="11274552" cy="5303520"/>
           </a:xfrm>
           <a:prstGeom prst="rect">
@@ -3724,7 +4042,7 @@
           <a:p>
             <a:pPr>
               <a:spcAft>
-                <a:spcPts val="1000"/>
+                <a:spcPts val="800"/>
               </a:spcAft>
               <a:defRPr sz="2800" b="1">
                 <a:solidFill>
@@ -3734,29 +4052,29 @@
               </a:defRPr>
             </a:pPr>
             <a:r>
-              <a:t>1. Acuerdos y Reglas de Clase</a:t>
-            </a:r>
-          </a:p>
-          <a:p>
-            <a:pPr>
+              <a:t>Decluttering:</a:t>
+            </a:r>
+          </a:p>
+          <a:p>
+            <a:pPr lvl="1">
               <a:spcAft>
-                <a:spcPts val="1000"/>
+                <a:spcPts val="800"/>
               </a:spcAft>
-              <a:defRPr sz="2800" b="1">
-                <a:solidFill>
-                  <a:srgbClr val="E85C0B"/>
+              <a:defRPr sz="2400" b="0">
+                <a:solidFill>
+                  <a:srgbClr val="003865"/>
                 </a:solidFill>
                 <a:latin typeface="Century Gothic"/>
               </a:defRPr>
             </a:pPr>
             <a:r>
-              <a:t>2. Estrategia EMI (Warm-up en Inglés)</a:t>
+              <a:t>Remueve bordes, ejes redundantes y gridlines.</a:t>
             </a:r>
           </a:p>
           <a:p>
             <a:pPr>
               <a:spcAft>
-                <a:spcPts val="1000"/>
+                <a:spcPts val="800"/>
               </a:spcAft>
               <a:defRPr sz="2800" b="1">
                 <a:solidFill>
@@ -3766,29 +4084,29 @@
               </a:defRPr>
             </a:pPr>
             <a:r>
-              <a:t>3. ¿Qué es Inteligencia de Negocios (BI)?</a:t>
-            </a:r>
-          </a:p>
-          <a:p>
-            <a:pPr>
+              <a:t>Gestalt:</a:t>
+            </a:r>
+          </a:p>
+          <a:p>
+            <a:pPr lvl="1">
               <a:spcAft>
-                <a:spcPts val="1000"/>
+                <a:spcPts val="800"/>
               </a:spcAft>
-              <a:defRPr sz="2800" b="1">
-                <a:solidFill>
-                  <a:srgbClr val="E85C0B"/>
+              <a:defRPr sz="2400" b="0">
+                <a:solidFill>
+                  <a:srgbClr val="003865"/>
                 </a:solidFill>
                 <a:latin typeface="Century Gothic"/>
               </a:defRPr>
             </a:pPr>
             <a:r>
-              <a:t>4. Glosario Técnico y Fundamentos Analíticos</a:t>
+              <a:t>El cerebro agrupa objetos por proximidad. Agrupa los KPIs similares.</a:t>
             </a:r>
           </a:p>
           <a:p>
             <a:pPr>
               <a:spcAft>
-                <a:spcPts val="1000"/>
+                <a:spcPts val="800"/>
               </a:spcAft>
               <a:defRPr sz="2800" b="1">
                 <a:solidFill>
@@ -3798,39 +4116,23 @@
               </a:defRPr>
             </a:pPr>
             <a:r>
-              <a:t>5. Storytelling with Data (Knaflic)</a:t>
-            </a:r>
-          </a:p>
-          <a:p>
-            <a:pPr>
+              <a:t>Colores Focales:</a:t>
+            </a:r>
+          </a:p>
+          <a:p>
+            <a:pPr lvl="1">
               <a:spcAft>
-                <a:spcPts val="1000"/>
+                <a:spcPts val="800"/>
               </a:spcAft>
-              <a:defRPr sz="2800" b="1">
-                <a:solidFill>
-                  <a:srgbClr val="E85C0B"/>
+              <a:defRPr sz="2400" b="0">
+                <a:solidFill>
+                  <a:srgbClr val="003865"/>
                 </a:solidFill>
                 <a:latin typeface="Century Gothic"/>
               </a:defRPr>
             </a:pPr>
             <a:r>
-              <a:t>6. Taller Práctico: Pair Programming</a:t>
-            </a:r>
-          </a:p>
-          <a:p>
-            <a:pPr>
-              <a:spcAft>
-                <a:spcPts val="1000"/>
-              </a:spcAft>
-              <a:defRPr sz="2800" b="1">
-                <a:solidFill>
-                  <a:srgbClr val="E85C0B"/>
-                </a:solidFill>
-                <a:latin typeface="Century Gothic"/>
-              </a:defRPr>
-            </a:pPr>
-            <a:r>
-              <a:t>7. Conclusiones y Bibliografía</a:t>
+              <a:t>Un solo color llamativo para el hallazgo, el resto en gris o azul oscuro.</a:t>
             </a:r>
           </a:p>
         </p:txBody>
@@ -3843,7 +4145,7 @@
 </p:sld>
 </file>
 
-<file path=ppt/slides/slide3.xml><?xml version="1.0" encoding="utf-8"?>
+<file path=ppt/slides/slide7.xml><?xml version="1.0" encoding="utf-8"?>
 <p:sld xmlns:a="http://schemas.openxmlformats.org/drawingml/2006/main" xmlns:p="http://schemas.openxmlformats.org/presentationml/2006/main" xmlns:r="http://schemas.openxmlformats.org/officeDocument/2006/relationships">
   <p:cSld>
     <p:bg>
@@ -3885,13 +4187,98 @@
           <a:p>
             <a:pPr algn="l"/>
             <a:r>
-              <a:rPr sz="4000" b="1">
+              <a:rPr sz="3500" b="1">
                 <a:solidFill>
                   <a:srgbClr val="003865"/>
                 </a:solidFill>
                 <a:latin typeface="Century Gothic"/>
               </a:rPr>
-              <a:t>Acuerdos de Clase</a:t>
+              <a:t>El Dashboard Minimalista</a:t>
+            </a:r>
+          </a:p>
+        </p:txBody>
+      </p:sp>
+      <p:pic>
+        <p:nvPicPr>
+          <p:cNvPr id="3" name="Picture 2" descr="dashboard_mockup.png"/>
+          <p:cNvPicPr>
+            <a:picLocks noChangeAspect="1"/>
+          </p:cNvPicPr>
+          <p:nvPr/>
+        </p:nvPicPr>
+        <p:blipFill>
+          <a:blip r:embed="rId2"/>
+          <a:stretch>
+            <a:fillRect/>
+          </a:stretch>
+        </p:blipFill>
+        <p:spPr>
+          <a:xfrm>
+            <a:off x="1371600" y="1371600"/>
+            <a:ext cx="9445752" cy="9445752"/>
+          </a:xfrm>
+          <a:prstGeom prst="rect">
+            <a:avLst/>
+          </a:prstGeom>
+        </p:spPr>
+      </p:pic>
+    </p:spTree>
+  </p:cSld>
+  <p:clrMapOvr>
+    <a:masterClrMapping/>
+  </p:clrMapOvr>
+</p:sld>
+</file>
+
+<file path=ppt/slides/slide8.xml><?xml version="1.0" encoding="utf-8"?>
+<p:sld xmlns:a="http://schemas.openxmlformats.org/drawingml/2006/main" xmlns:p="http://schemas.openxmlformats.org/presentationml/2006/main" xmlns:r="http://schemas.openxmlformats.org/officeDocument/2006/relationships">
+  <p:cSld>
+    <p:bg>
+      <p:bgPr>
+        <a:solidFill>
+          <a:srgbClr val="F0F0F0"/>
+        </a:solidFill>
+        <a:effectLst/>
+      </p:bgPr>
+    </p:bg>
+    <p:spTree>
+      <p:nvGrpSpPr>
+        <p:cNvPr id="1" name=""/>
+        <p:cNvGrpSpPr/>
+        <p:nvPr/>
+      </p:nvGrpSpPr>
+      <p:grpSpPr/>
+      <p:sp>
+        <p:nvSpPr>
+          <p:cNvPr id="2" name="TextBox 1"/>
+          <p:cNvSpPr txBox="1"/>
+          <p:nvPr/>
+        </p:nvSpPr>
+        <p:spPr>
+          <a:xfrm>
+            <a:off x="457200" y="182880"/>
+            <a:ext cx="11274552" cy="914400"/>
+          </a:xfrm>
+          <a:prstGeom prst="rect">
+            <a:avLst/>
+          </a:prstGeom>
+          <a:noFill/>
+        </p:spPr>
+        <p:txBody>
+          <a:bodyPr wrap="none">
+            <a:spAutoFit/>
+          </a:bodyPr>
+          <a:lstStyle/>
+          <a:p>
+            <a:pPr algn="l"/>
+            <a:r>
+              <a:rPr sz="3600" b="1">
+                <a:solidFill>
+                  <a:srgbClr val="003865"/>
+                </a:solidFill>
+                <a:latin typeface="Century Gothic"/>
+              </a:rPr>
+              <a:t>Conclusiones</a:t>
             </a:r>
           </a:p>
         </p:txBody>
@@ -3904,7 +4291,7 @@
         </p:nvSpPr>
         <p:spPr>
           <a:xfrm>
-            <a:off x="457200" y="1097280"/>
+            <a:off x="457200" y="1005840"/>
             <a:ext cx="11274552" cy="45720"/>
           </a:xfrm>
           <a:prstGeom prst="rect">
@@ -3949,7 +4336,7 @@
         </p:nvSpPr>
         <p:spPr>
           <a:xfrm>
-            <a:off x="457200" y="1280160"/>
+            <a:off x="457200" y="1188720"/>
             <a:ext cx="11274552" cy="5303520"/>
           </a:xfrm>
           <a:prstGeom prst="rect">
@@ -3966,7 +4353,7 @@
           <a:p>
             <a:pPr>
               <a:spcAft>
-                <a:spcPts val="1000"/>
+                <a:spcPts val="800"/>
               </a:spcAft>
               <a:defRPr sz="2600" b="1">
                 <a:solidFill>
@@ -3976,15 +4363,15 @@
               </a:defRPr>
             </a:pPr>
             <a:r>
-              <a:t>Horario Oficial: Viernes de 10:00 AM a 1:00 PM.</a:t>
-            </a:r>
-          </a:p>
-          <a:p>
-            <a:pPr lvl="1">
+              <a:t>El diseño de datos es estrategia organizacional.</a:t>
+            </a:r>
+          </a:p>
+          <a:p>
+            <a:pPr>
               <a:spcAft>
-                <a:spcPts val="1000"/>
+                <a:spcPts val="800"/>
               </a:spcAft>
-              <a:defRPr sz="2200" b="0">
+              <a:defRPr sz="2600" b="1">
                 <a:solidFill>
                   <a:srgbClr val="003865"/>
                 </a:solidFill>
@@ -3992,1317 +4379,7 @@
               </a:defRPr>
             </a:pPr>
             <a:r>
-              <a:t>Puntualidad: Llegar a tiempo garantiza no perder conceptos clave.</a:t>
-            </a:r>
-          </a:p>
-          <a:p>
-            <a:pPr lvl="1">
-              <a:spcAft>
-                <a:spcPts val="1000"/>
-              </a:spcAft>
-              <a:defRPr sz="2200" b="0">
-                <a:solidFill>
-                  <a:srgbClr val="003865"/>
-                </a:solidFill>
-                <a:latin typeface="Century Gothic"/>
-              </a:defRPr>
-            </a:pPr>
-            <a:r>
-              <a:t>Descansos Cognitivos: Haremos una pausa a las 11:30 AM para evitar fatiga técnica.</a:t>
-            </a:r>
-          </a:p>
-          <a:p>
-            <a:pPr lvl="1">
-              <a:spcAft>
-                <a:spcPts val="1000"/>
-              </a:spcAft>
-              <a:defRPr sz="2200" b="0">
-                <a:solidFill>
-                  <a:srgbClr val="003865"/>
-                </a:solidFill>
-                <a:latin typeface="Century Gothic"/>
-              </a:defRPr>
-            </a:pPr>
-            <a:r>
-              <a:t>Estrategia EMI: 10 a 15 minutos de inmersión en inglés técnico por sesión.</a:t>
-            </a:r>
-          </a:p>
-        </p:txBody>
-      </p:sp>
-    </p:spTree>
-  </p:cSld>
-  <p:clrMapOvr>
-    <a:masterClrMapping/>
-  </p:clrMapOvr>
-</p:sld>
-</file>
-
-<file path=ppt/slides/slide4.xml><?xml version="1.0" encoding="utf-8"?>
-<p:sld xmlns:a="http://schemas.openxmlformats.org/drawingml/2006/main" xmlns:p="http://schemas.openxmlformats.org/presentationml/2006/main" xmlns:r="http://schemas.openxmlformats.org/officeDocument/2006/relationships">
-  <p:cSld>
-    <p:bg>
-      <p:bgPr>
-        <a:solidFill>
-          <a:srgbClr val="F0F0F0"/>
-        </a:solidFill>
-        <a:effectLst/>
-      </p:bgPr>
-    </p:bg>
-    <p:spTree>
-      <p:nvGrpSpPr>
-        <p:cNvPr id="1" name=""/>
-        <p:cNvGrpSpPr/>
-        <p:nvPr/>
-      </p:nvGrpSpPr>
-      <p:grpSpPr/>
-      <p:sp>
-        <p:nvSpPr>
-          <p:cNvPr id="2" name="TextBox 1"/>
-          <p:cNvSpPr txBox="1"/>
-          <p:nvPr/>
-        </p:nvSpPr>
-        <p:spPr>
-          <a:xfrm>
-            <a:off x="457200" y="182880"/>
-            <a:ext cx="11274552" cy="914400"/>
-          </a:xfrm>
-          <a:prstGeom prst="rect">
-            <a:avLst/>
-          </a:prstGeom>
-          <a:noFill/>
-        </p:spPr>
-        <p:txBody>
-          <a:bodyPr wrap="none">
-            <a:spAutoFit/>
-          </a:bodyPr>
-          <a:lstStyle/>
-          <a:p>
-            <a:pPr algn="l"/>
-            <a:r>
-              <a:rPr sz="4000" b="1">
-                <a:solidFill>
-                  <a:srgbClr val="003865"/>
-                </a:solidFill>
-                <a:latin typeface="Century Gothic"/>
-              </a:rPr>
-              <a:t>🇬🇧 EMI Strategy: Warm-Up</a:t>
-            </a:r>
-          </a:p>
-        </p:txBody>
-      </p:sp>
-      <p:sp>
-        <p:nvSpPr>
-          <p:cNvPr id="3" name="Rectangle 2"/>
-          <p:cNvSpPr/>
-          <p:nvPr/>
-        </p:nvSpPr>
-        <p:spPr>
-          <a:xfrm>
-            <a:off x="457200" y="1097280"/>
-            <a:ext cx="11274552" cy="45720"/>
-          </a:xfrm>
-          <a:prstGeom prst="rect">
-            <a:avLst/>
-          </a:prstGeom>
-          <a:solidFill>
-            <a:srgbClr val="E85C0B"/>
-          </a:solidFill>
-          <a:ln>
-            <a:solidFill>
-              <a:srgbClr val="E85C0B"/>
-            </a:solidFill>
-          </a:ln>
-        </p:spPr>
-        <p:style>
-          <a:lnRef idx="1">
-            <a:schemeClr val="accent1"/>
-          </a:lnRef>
-          <a:fillRef idx="3">
-            <a:schemeClr val="accent1"/>
-          </a:fillRef>
-          <a:effectRef idx="2">
-            <a:schemeClr val="accent1"/>
-          </a:effectRef>
-          <a:fontRef idx="minor">
-            <a:schemeClr val="lt1"/>
-          </a:fontRef>
-        </p:style>
-        <p:txBody>
-          <a:bodyPr rtlCol="0" anchor="ctr"/>
-          <a:lstStyle/>
-          <a:p>
-            <a:pPr algn="ctr"/>
-          </a:p>
-        </p:txBody>
-      </p:sp>
-      <p:sp>
-        <p:nvSpPr>
-          <p:cNvPr id="4" name="TextBox 3"/>
-          <p:cNvSpPr txBox="1"/>
-          <p:nvPr/>
-        </p:nvSpPr>
-        <p:spPr>
-          <a:xfrm>
-            <a:off x="457200" y="1280160"/>
-            <a:ext cx="11274552" cy="5303520"/>
-          </a:xfrm>
-          <a:prstGeom prst="rect">
-            <a:avLst/>
-          </a:prstGeom>
-          <a:noFill/>
-        </p:spPr>
-        <p:txBody>
-          <a:bodyPr wrap="square">
-            <a:spAutoFit/>
-          </a:bodyPr>
-          <a:lstStyle/>
-          <a:p/>
-          <a:p>
-            <a:pPr>
-              <a:spcAft>
-                <a:spcPts val="1000"/>
-              </a:spcAft>
-              <a:defRPr sz="3200" b="1">
-                <a:solidFill>
-                  <a:srgbClr val="003865"/>
-                </a:solidFill>
-                <a:latin typeface="Century Gothic"/>
-              </a:defRPr>
-            </a:pPr>
-            <a:r>
-              <a:t>Let's activate our English and BI Vocabulary!</a:t>
-            </a:r>
-          </a:p>
-          <a:p>
-            <a:br/>
-            <a:pPr>
-              <a:spcAft>
-                <a:spcPts val="1000"/>
-              </a:spcAft>
-              <a:defRPr sz="2800" b="0">
-                <a:solidFill>
-                  <a:srgbClr val="003865"/>
-                </a:solidFill>
-                <a:latin typeface="Century Gothic"/>
-              </a:defRPr>
-            </a:pPr>
-            <a:r>
-              <a:t>Actividad Interactiva:</a:t>
-            </a:r>
-          </a:p>
-          <a:p>
-            <a:pPr lvl="1">
-              <a:spcAft>
-                <a:spcPts val="1000"/>
-              </a:spcAft>
-              <a:defRPr sz="2600" b="1">
-                <a:solidFill>
-                  <a:srgbClr val="E85C0B"/>
-                </a:solidFill>
-                <a:latin typeface="Century Gothic"/>
-              </a:defRPr>
-            </a:pPr>
-            <a:r>
-              <a:t>Abran el archivo quiz_semana_1.html en sus navegadores.</a:t>
-            </a:r>
-          </a:p>
-          <a:p>
-            <a:pPr lvl="1">
-              <a:spcAft>
-                <a:spcPts val="1000"/>
-              </a:spcAft>
-              <a:defRPr sz="2200" b="0">
-                <a:solidFill>
-                  <a:srgbClr val="003865"/>
-                </a:solidFill>
-                <a:latin typeface="Century Gothic"/>
-              </a:defRPr>
-            </a:pPr>
-            <a:r>
-              <a:t>Vamos a emparejar los conceptos (Dashboard, KPI, Data-Driven) con su definición.</a:t>
-            </a:r>
-          </a:p>
-        </p:txBody>
-      </p:sp>
-    </p:spTree>
-  </p:cSld>
-  <p:clrMapOvr>
-    <a:masterClrMapping/>
-  </p:clrMapOvr>
-</p:sld>
-</file>
-
-<file path=ppt/slides/slide5.xml><?xml version="1.0" encoding="utf-8"?>
-<p:sld xmlns:a="http://schemas.openxmlformats.org/drawingml/2006/main" xmlns:p="http://schemas.openxmlformats.org/presentationml/2006/main" xmlns:r="http://schemas.openxmlformats.org/officeDocument/2006/relationships">
-  <p:cSld>
-    <p:bg>
-      <p:bgPr>
-        <a:solidFill>
-          <a:srgbClr val="F0F0F0"/>
-        </a:solidFill>
-        <a:effectLst/>
-      </p:bgPr>
-    </p:bg>
-    <p:spTree>
-      <p:nvGrpSpPr>
-        <p:cNvPr id="1" name=""/>
-        <p:cNvGrpSpPr/>
-        <p:nvPr/>
-      </p:nvGrpSpPr>
-      <p:grpSpPr/>
-      <p:sp>
-        <p:nvSpPr>
-          <p:cNvPr id="2" name="TextBox 1"/>
-          <p:cNvSpPr txBox="1"/>
-          <p:nvPr/>
-        </p:nvSpPr>
-        <p:spPr>
-          <a:xfrm>
-            <a:off x="457200" y="182880"/>
-            <a:ext cx="11274552" cy="914400"/>
-          </a:xfrm>
-          <a:prstGeom prst="rect">
-            <a:avLst/>
-          </a:prstGeom>
-          <a:noFill/>
-        </p:spPr>
-        <p:txBody>
-          <a:bodyPr wrap="none">
-            <a:spAutoFit/>
-          </a:bodyPr>
-          <a:lstStyle/>
-          <a:p>
-            <a:pPr algn="l"/>
-            <a:r>
-              <a:rPr sz="4000" b="1">
-                <a:solidFill>
-                  <a:srgbClr val="003865"/>
-                </a:solidFill>
-                <a:latin typeface="Century Gothic"/>
-              </a:rPr>
-              <a:t>¿Qué es la Inteligencia de Negocios?</a:t>
-            </a:r>
-          </a:p>
-        </p:txBody>
-      </p:sp>
-      <p:sp>
-        <p:nvSpPr>
-          <p:cNvPr id="3" name="Rectangle 2"/>
-          <p:cNvSpPr/>
-          <p:nvPr/>
-        </p:nvSpPr>
-        <p:spPr>
-          <a:xfrm>
-            <a:off x="457200" y="1097280"/>
-            <a:ext cx="11274552" cy="45720"/>
-          </a:xfrm>
-          <a:prstGeom prst="rect">
-            <a:avLst/>
-          </a:prstGeom>
-          <a:solidFill>
-            <a:srgbClr val="E85C0B"/>
-          </a:solidFill>
-          <a:ln>
-            <a:solidFill>
-              <a:srgbClr val="E85C0B"/>
-            </a:solidFill>
-          </a:ln>
-        </p:spPr>
-        <p:style>
-          <a:lnRef idx="1">
-            <a:schemeClr val="accent1"/>
-          </a:lnRef>
-          <a:fillRef idx="3">
-            <a:schemeClr val="accent1"/>
-          </a:fillRef>
-          <a:effectRef idx="2">
-            <a:schemeClr val="accent1"/>
-          </a:effectRef>
-          <a:fontRef idx="minor">
-            <a:schemeClr val="lt1"/>
-          </a:fontRef>
-        </p:style>
-        <p:txBody>
-          <a:bodyPr rtlCol="0" anchor="ctr"/>
-          <a:lstStyle/>
-          <a:p>
-            <a:pPr algn="ctr"/>
-          </a:p>
-        </p:txBody>
-      </p:sp>
-      <p:sp>
-        <p:nvSpPr>
-          <p:cNvPr id="4" name="TextBox 3"/>
-          <p:cNvSpPr txBox="1"/>
-          <p:nvPr/>
-        </p:nvSpPr>
-        <p:spPr>
-          <a:xfrm>
-            <a:off x="457200" y="1280160"/>
-            <a:ext cx="11274552" cy="5303520"/>
-          </a:xfrm>
-          <a:prstGeom prst="rect">
-            <a:avLst/>
-          </a:prstGeom>
-          <a:noFill/>
-        </p:spPr>
-        <p:txBody>
-          <a:bodyPr wrap="square">
-            <a:spAutoFit/>
-          </a:bodyPr>
-          <a:lstStyle/>
-          <a:p/>
-          <a:p>
-            <a:pPr>
-              <a:spcAft>
-                <a:spcPts val="1000"/>
-              </a:spcAft>
-              <a:defRPr sz="2800" b="1">
-                <a:solidFill>
-                  <a:srgbClr val="003865"/>
-                </a:solidFill>
-                <a:latin typeface="Century Gothic"/>
-              </a:defRPr>
-            </a:pPr>
-            <a:r>
-              <a:t>Definición Institucional (Sharda et al., 2020):</a:t>
-            </a:r>
-          </a:p>
-          <a:p>
-            <a:pPr lvl="1">
-              <a:spcAft>
-                <a:spcPts val="1000"/>
-              </a:spcAft>
-              <a:defRPr sz="2200" b="0">
-                <a:solidFill>
-                  <a:srgbClr val="003865"/>
-                </a:solidFill>
-                <a:latin typeface="Century Gothic"/>
-              </a:defRPr>
-            </a:pPr>
-            <a:r>
-              <a:t>Conjunto de estrategias, procesos y tecnologías enfocadas en la creación de conocimiento mediante análisis de datos.</a:t>
-            </a:r>
-          </a:p>
-          <a:p>
-            <a:br/>
-            <a:pPr>
-              <a:spcAft>
-                <a:spcPts val="1000"/>
-              </a:spcAft>
-              <a:defRPr sz="2800" b="1">
-                <a:solidFill>
-                  <a:srgbClr val="E85C0B"/>
-                </a:solidFill>
-                <a:latin typeface="Century Gothic"/>
-              </a:defRPr>
-            </a:pPr>
-            <a:r>
-              <a:t>El rol de la Analítica:</a:t>
-            </a:r>
-          </a:p>
-          <a:p>
-            <a:pPr lvl="1">
-              <a:spcAft>
-                <a:spcPts val="1000"/>
-              </a:spcAft>
-              <a:defRPr sz="2200" b="0">
-                <a:solidFill>
-                  <a:srgbClr val="003865"/>
-                </a:solidFill>
-                <a:latin typeface="Century Gothic"/>
-              </a:defRPr>
-            </a:pPr>
-            <a:r>
-              <a:t>- Descriptiva: ¿Qué sucedió? (Reportes históricos)</a:t>
-            </a:r>
-          </a:p>
-          <a:p>
-            <a:pPr lvl="1">
-              <a:spcAft>
-                <a:spcPts val="1000"/>
-              </a:spcAft>
-              <a:defRPr sz="2200" b="0">
-                <a:solidFill>
-                  <a:srgbClr val="003865"/>
-                </a:solidFill>
-                <a:latin typeface="Century Gothic"/>
-              </a:defRPr>
-            </a:pPr>
-            <a:r>
-              <a:t>- Predictiva: ¿Qué pasará? (Modelos predictivos, Machine Learning)</a:t>
-            </a:r>
-          </a:p>
-          <a:p>
-            <a:pPr lvl="1">
-              <a:spcAft>
-                <a:spcPts val="1000"/>
-              </a:spcAft>
-              <a:defRPr sz="2200" b="0">
-                <a:solidFill>
-                  <a:srgbClr val="003865"/>
-                </a:solidFill>
-                <a:latin typeface="Century Gothic"/>
-              </a:defRPr>
-            </a:pPr>
-            <a:r>
-              <a:t>- Prescriptiva: ¿Qué debemos hacer? (Optimización, Simulación)</a:t>
-            </a:r>
-          </a:p>
-        </p:txBody>
-      </p:sp>
-    </p:spTree>
-  </p:cSld>
-  <p:clrMapOvr>
-    <a:masterClrMapping/>
-  </p:clrMapOvr>
-</p:sld>
-</file>
-
-<file path=ppt/slides/slide6.xml><?xml version="1.0" encoding="utf-8"?>
-<p:sld xmlns:a="http://schemas.openxmlformats.org/drawingml/2006/main" xmlns:p="http://schemas.openxmlformats.org/presentationml/2006/main" xmlns:r="http://schemas.openxmlformats.org/officeDocument/2006/relationships">
-  <p:cSld>
-    <p:bg>
-      <p:bgPr>
-        <a:solidFill>
-          <a:srgbClr val="F0F0F0"/>
-        </a:solidFill>
-        <a:effectLst/>
-      </p:bgPr>
-    </p:bg>
-    <p:spTree>
-      <p:nvGrpSpPr>
-        <p:cNvPr id="1" name=""/>
-        <p:cNvGrpSpPr/>
-        <p:nvPr/>
-      </p:nvGrpSpPr>
-      <p:grpSpPr/>
-      <p:sp>
-        <p:nvSpPr>
-          <p:cNvPr id="2" name="TextBox 1"/>
-          <p:cNvSpPr txBox="1"/>
-          <p:nvPr/>
-        </p:nvSpPr>
-        <p:spPr>
-          <a:xfrm>
-            <a:off x="457200" y="182880"/>
-            <a:ext cx="11274552" cy="914400"/>
-          </a:xfrm>
-          <a:prstGeom prst="rect">
-            <a:avLst/>
-          </a:prstGeom>
-          <a:noFill/>
-        </p:spPr>
-        <p:txBody>
-          <a:bodyPr wrap="none">
-            <a:spAutoFit/>
-          </a:bodyPr>
-          <a:lstStyle/>
-          <a:p>
-            <a:pPr algn="l"/>
-            <a:r>
-              <a:rPr sz="4000" b="1">
-                <a:solidFill>
-                  <a:srgbClr val="003865"/>
-                </a:solidFill>
-                <a:latin typeface="Century Gothic"/>
-              </a:rPr>
-              <a:t>Glosario Técnico de BI</a:t>
-            </a:r>
-          </a:p>
-        </p:txBody>
-      </p:sp>
-      <p:sp>
-        <p:nvSpPr>
-          <p:cNvPr id="3" name="Rectangle 2"/>
-          <p:cNvSpPr/>
-          <p:nvPr/>
-        </p:nvSpPr>
-        <p:spPr>
-          <a:xfrm>
-            <a:off x="457200" y="1097280"/>
-            <a:ext cx="11274552" cy="45720"/>
-          </a:xfrm>
-          <a:prstGeom prst="rect">
-            <a:avLst/>
-          </a:prstGeom>
-          <a:solidFill>
-            <a:srgbClr val="E85C0B"/>
-          </a:solidFill>
-          <a:ln>
-            <a:solidFill>
-              <a:srgbClr val="E85C0B"/>
-            </a:solidFill>
-          </a:ln>
-        </p:spPr>
-        <p:style>
-          <a:lnRef idx="1">
-            <a:schemeClr val="accent1"/>
-          </a:lnRef>
-          <a:fillRef idx="3">
-            <a:schemeClr val="accent1"/>
-          </a:fillRef>
-          <a:effectRef idx="2">
-            <a:schemeClr val="accent1"/>
-          </a:effectRef>
-          <a:fontRef idx="minor">
-            <a:schemeClr val="lt1"/>
-          </a:fontRef>
-        </p:style>
-        <p:txBody>
-          <a:bodyPr rtlCol="0" anchor="ctr"/>
-          <a:lstStyle/>
-          <a:p>
-            <a:pPr algn="ctr"/>
-          </a:p>
-        </p:txBody>
-      </p:sp>
-      <p:sp>
-        <p:nvSpPr>
-          <p:cNvPr id="4" name="TextBox 3"/>
-          <p:cNvSpPr txBox="1"/>
-          <p:nvPr/>
-        </p:nvSpPr>
-        <p:spPr>
-          <a:xfrm>
-            <a:off x="457200" y="1280160"/>
-            <a:ext cx="11274552" cy="5303520"/>
-          </a:xfrm>
-          <a:prstGeom prst="rect">
-            <a:avLst/>
-          </a:prstGeom>
-          <a:noFill/>
-        </p:spPr>
-        <p:txBody>
-          <a:bodyPr wrap="square">
-            <a:spAutoFit/>
-          </a:bodyPr>
-          <a:lstStyle/>
-          <a:p/>
-          <a:p>
-            <a:pPr>
-              <a:spcAft>
-                <a:spcPts val="1000"/>
-              </a:spcAft>
-              <a:defRPr sz="2600" b="1">
-                <a:solidFill>
-                  <a:srgbClr val="003865"/>
-                </a:solidFill>
-                <a:latin typeface="Century Gothic"/>
-              </a:defRPr>
-            </a:pPr>
-            <a:r>
-              <a:t>ETL (Extract, Transform, Load):</a:t>
-            </a:r>
-          </a:p>
-          <a:p>
-            <a:pPr lvl="1">
-              <a:spcAft>
-                <a:spcPts val="1000"/>
-              </a:spcAft>
-              <a:defRPr sz="2000" b="0">
-                <a:solidFill>
-                  <a:srgbClr val="003865"/>
-                </a:solidFill>
-                <a:latin typeface="Century Gothic"/>
-              </a:defRPr>
-            </a:pPr>
-            <a:r>
-              <a:t>Extraer datos, transformarlos al formato analítico y cargarlos. El 80% del trabajo en BI ocurre aquí.</a:t>
-            </a:r>
-          </a:p>
-          <a:p>
-            <a:pPr>
-              <a:spcAft>
-                <a:spcPts val="1000"/>
-              </a:spcAft>
-              <a:defRPr sz="2600" b="1">
-                <a:solidFill>
-                  <a:srgbClr val="003865"/>
-                </a:solidFill>
-                <a:latin typeface="Century Gothic"/>
-              </a:defRPr>
-            </a:pPr>
-            <a:r>
-              <a:t>OLTP vs OLAP:</a:t>
-            </a:r>
-          </a:p>
-          <a:p>
-            <a:pPr lvl="1">
-              <a:spcAft>
-                <a:spcPts val="1000"/>
-              </a:spcAft>
-              <a:defRPr sz="2000" b="0">
-                <a:solidFill>
-                  <a:srgbClr val="003865"/>
-                </a:solidFill>
-                <a:latin typeface="Century Gothic"/>
-              </a:defRPr>
-            </a:pPr>
-            <a:r>
-              <a:t>OLTP: Transacciones rápidas diarias (Ej. Caja Registradora). Altamente normalizado.</a:t>
-            </a:r>
-          </a:p>
-          <a:p>
-            <a:pPr lvl="1">
-              <a:spcAft>
-                <a:spcPts val="1000"/>
-              </a:spcAft>
-              <a:defRPr sz="2000" b="0">
-                <a:solidFill>
-                  <a:srgbClr val="003865"/>
-                </a:solidFill>
-                <a:latin typeface="Century Gothic"/>
-              </a:defRPr>
-            </a:pPr>
-            <a:r>
-              <a:t>OLAP: Consultas analíticas complejas y agregaciones (Cubo de Datos).</a:t>
-            </a:r>
-          </a:p>
-          <a:p>
-            <a:pPr>
-              <a:spcAft>
-                <a:spcPts val="1000"/>
-              </a:spcAft>
-              <a:defRPr sz="2600" b="1">
-                <a:solidFill>
-                  <a:srgbClr val="003865"/>
-                </a:solidFill>
-                <a:latin typeface="Century Gothic"/>
-              </a:defRPr>
-            </a:pPr>
-            <a:r>
-              <a:t>Data Warehouse &amp; Data Mart:</a:t>
-            </a:r>
-          </a:p>
-          <a:p>
-            <a:pPr lvl="1">
-              <a:spcAft>
-                <a:spcPts val="1000"/>
-              </a:spcAft>
-              <a:defRPr sz="2000" b="0">
-                <a:solidFill>
-                  <a:srgbClr val="003865"/>
-                </a:solidFill>
-                <a:latin typeface="Century Gothic"/>
-              </a:defRPr>
-            </a:pPr>
-            <a:r>
-              <a:t>Data Warehouse: Repositorio centralizado de datos de toda la corporación.</a:t>
-            </a:r>
-          </a:p>
-          <a:p>
-            <a:pPr lvl="1">
-              <a:spcAft>
-                <a:spcPts val="1000"/>
-              </a:spcAft>
-              <a:defRPr sz="2000" b="0">
-                <a:solidFill>
-                  <a:srgbClr val="003865"/>
-                </a:solidFill>
-                <a:latin typeface="Century Gothic"/>
-              </a:defRPr>
-            </a:pPr>
-            <a:r>
-              <a:t>Data Mart: Una subdivisión del Warehouse para un solo departamento (Ej. Finanzas).</a:t>
-            </a:r>
-          </a:p>
-        </p:txBody>
-      </p:sp>
-    </p:spTree>
-  </p:cSld>
-  <p:clrMapOvr>
-    <a:masterClrMapping/>
-  </p:clrMapOvr>
-</p:sld>
-</file>
-
-<file path=ppt/slides/slide7.xml><?xml version="1.0" encoding="utf-8"?>
-<p:sld xmlns:a="http://schemas.openxmlformats.org/drawingml/2006/main" xmlns:p="http://schemas.openxmlformats.org/presentationml/2006/main" xmlns:r="http://schemas.openxmlformats.org/officeDocument/2006/relationships">
-  <p:cSld>
-    <p:bg>
-      <p:bgPr>
-        <a:solidFill>
-          <a:srgbClr val="F0F0F0"/>
-        </a:solidFill>
-        <a:effectLst/>
-      </p:bgPr>
-    </p:bg>
-    <p:spTree>
-      <p:nvGrpSpPr>
-        <p:cNvPr id="1" name=""/>
-        <p:cNvGrpSpPr/>
-        <p:nvPr/>
-      </p:nvGrpSpPr>
-      <p:grpSpPr/>
-      <p:sp>
-        <p:nvSpPr>
-          <p:cNvPr id="2" name="TextBox 1"/>
-          <p:cNvSpPr txBox="1"/>
-          <p:nvPr/>
-        </p:nvSpPr>
-        <p:spPr>
-          <a:xfrm>
-            <a:off x="457200" y="182880"/>
-            <a:ext cx="11274552" cy="914400"/>
-          </a:xfrm>
-          <a:prstGeom prst="rect">
-            <a:avLst/>
-          </a:prstGeom>
-          <a:noFill/>
-        </p:spPr>
-        <p:txBody>
-          <a:bodyPr wrap="none">
-            <a:spAutoFit/>
-          </a:bodyPr>
-          <a:lstStyle/>
-          <a:p>
-            <a:pPr algn="l"/>
-            <a:r>
-              <a:rPr sz="4000" b="1">
-                <a:solidFill>
-                  <a:srgbClr val="003865"/>
-                </a:solidFill>
-                <a:latin typeface="Century Gothic"/>
-              </a:rPr>
-              <a:t>Storytelling con Datos</a:t>
-            </a:r>
-          </a:p>
-        </p:txBody>
-      </p:sp>
-      <p:sp>
-        <p:nvSpPr>
-          <p:cNvPr id="3" name="Rectangle 2"/>
-          <p:cNvSpPr/>
-          <p:nvPr/>
-        </p:nvSpPr>
-        <p:spPr>
-          <a:xfrm>
-            <a:off x="457200" y="1097280"/>
-            <a:ext cx="11274552" cy="45720"/>
-          </a:xfrm>
-          <a:prstGeom prst="rect">
-            <a:avLst/>
-          </a:prstGeom>
-          <a:solidFill>
-            <a:srgbClr val="E85C0B"/>
-          </a:solidFill>
-          <a:ln>
-            <a:solidFill>
-              <a:srgbClr val="E85C0B"/>
-            </a:solidFill>
-          </a:ln>
-        </p:spPr>
-        <p:style>
-          <a:lnRef idx="1">
-            <a:schemeClr val="accent1"/>
-          </a:lnRef>
-          <a:fillRef idx="3">
-            <a:schemeClr val="accent1"/>
-          </a:fillRef>
-          <a:effectRef idx="2">
-            <a:schemeClr val="accent1"/>
-          </a:effectRef>
-          <a:fontRef idx="minor">
-            <a:schemeClr val="lt1"/>
-          </a:fontRef>
-        </p:style>
-        <p:txBody>
-          <a:bodyPr rtlCol="0" anchor="ctr"/>
-          <a:lstStyle/>
-          <a:p>
-            <a:pPr algn="ctr"/>
-          </a:p>
-        </p:txBody>
-      </p:sp>
-      <p:sp>
-        <p:nvSpPr>
-          <p:cNvPr id="4" name="TextBox 3"/>
-          <p:cNvSpPr txBox="1"/>
-          <p:nvPr/>
-        </p:nvSpPr>
-        <p:spPr>
-          <a:xfrm>
-            <a:off x="457200" y="1280160"/>
-            <a:ext cx="11274552" cy="5303520"/>
-          </a:xfrm>
-          <a:prstGeom prst="rect">
-            <a:avLst/>
-          </a:prstGeom>
-          <a:noFill/>
-        </p:spPr>
-        <p:txBody>
-          <a:bodyPr wrap="square">
-            <a:spAutoFit/>
-          </a:bodyPr>
-          <a:lstStyle/>
-          <a:p/>
-          <a:p>
-            <a:pPr>
-              <a:spcAft>
-                <a:spcPts val="1000"/>
-              </a:spcAft>
-              <a:defRPr sz="2800" b="1">
-                <a:solidFill>
-                  <a:srgbClr val="E85C0B"/>
-                </a:solidFill>
-                <a:latin typeface="Century Gothic"/>
-              </a:defRPr>
-            </a:pPr>
-            <a:r>
-              <a:t>Principios de Diseño Visual (Knaflic, 2015):</a:t>
-            </a:r>
-          </a:p>
-          <a:p>
-            <a:pPr>
-              <a:spcAft>
-                <a:spcPts val="1000"/>
-              </a:spcAft>
-              <a:defRPr sz="2400" b="1">
-                <a:solidFill>
-                  <a:srgbClr val="003865"/>
-                </a:solidFill>
-                <a:latin typeface="Century Gothic"/>
-              </a:defRPr>
-            </a:pPr>
-            <a:r>
-              <a:t>1. Eliminar el desorden (Declutter):</a:t>
-            </a:r>
-          </a:p>
-          <a:p>
-            <a:pPr lvl="1">
-              <a:spcAft>
-                <a:spcPts val="1000"/>
-              </a:spcAft>
-              <a:defRPr sz="2000" b="0">
-                <a:solidFill>
-                  <a:srgbClr val="003865"/>
-                </a:solidFill>
-                <a:latin typeface="Century Gothic"/>
-              </a:defRPr>
-            </a:pPr>
-            <a:r>
-              <a:t>Elimina bordes de gráficos, gridlines de fondo, colores innecesarios y sombras.</a:t>
-            </a:r>
-          </a:p>
-          <a:p>
-            <a:pPr>
-              <a:spcAft>
-                <a:spcPts val="1000"/>
-              </a:spcAft>
-              <a:defRPr sz="2400" b="1">
-                <a:solidFill>
-                  <a:srgbClr val="003865"/>
-                </a:solidFill>
-                <a:latin typeface="Century Gothic"/>
-              </a:defRPr>
-            </a:pPr>
-            <a:r>
-              <a:t>2. Dirigir la Atención (Principios Gestalt):</a:t>
-            </a:r>
-          </a:p>
-          <a:p>
-            <a:pPr lvl="1">
-              <a:spcAft>
-                <a:spcPts val="1000"/>
-              </a:spcAft>
-              <a:defRPr sz="2000" b="0">
-                <a:solidFill>
-                  <a:srgbClr val="003865"/>
-                </a:solidFill>
-                <a:latin typeface="Century Gothic"/>
-              </a:defRPr>
-            </a:pPr>
-            <a:r>
-              <a:t>Usa colores vibrantes (naranja) SOLO para los datos clave. El resto en tonos neutros (gris/azul).</a:t>
-            </a:r>
-          </a:p>
-          <a:p>
-            <a:pPr>
-              <a:spcAft>
-                <a:spcPts val="1000"/>
-              </a:spcAft>
-              <a:defRPr sz="2400" b="1">
-                <a:solidFill>
-                  <a:srgbClr val="003865"/>
-                </a:solidFill>
-                <a:latin typeface="Century Gothic"/>
-              </a:defRPr>
-            </a:pPr>
-            <a:r>
-              <a:t>3. Evitar el 3D a toda costa:</a:t>
-            </a:r>
-          </a:p>
-          <a:p>
-            <a:pPr lvl="1">
-              <a:spcAft>
-                <a:spcPts val="1000"/>
-              </a:spcAft>
-              <a:defRPr sz="2000" b="0">
-                <a:solidFill>
-                  <a:srgbClr val="003865"/>
-                </a:solidFill>
-                <a:latin typeface="Century Gothic"/>
-              </a:defRPr>
-            </a:pPr>
-            <a:r>
-              <a:t>Los gráficos 3D (especialmente Pie Charts) distorsionan la percepción geométrica del cerebro.</a:t>
-            </a:r>
-          </a:p>
-        </p:txBody>
-      </p:sp>
-    </p:spTree>
-  </p:cSld>
-  <p:clrMapOvr>
-    <a:masterClrMapping/>
-  </p:clrMapOvr>
-</p:sld>
-</file>
-
-<file path=ppt/slides/slide8.xml><?xml version="1.0" encoding="utf-8"?>
-<p:sld xmlns:a="http://schemas.openxmlformats.org/drawingml/2006/main" xmlns:p="http://schemas.openxmlformats.org/presentationml/2006/main" xmlns:r="http://schemas.openxmlformats.org/officeDocument/2006/relationships">
-  <p:cSld>
-    <p:bg>
-      <p:bgPr>
-        <a:solidFill>
-          <a:srgbClr val="F0F0F0"/>
-        </a:solidFill>
-        <a:effectLst/>
-      </p:bgPr>
-    </p:bg>
-    <p:spTree>
-      <p:nvGrpSpPr>
-        <p:cNvPr id="1" name=""/>
-        <p:cNvGrpSpPr/>
-        <p:nvPr/>
-      </p:nvGrpSpPr>
-      <p:grpSpPr/>
-      <p:sp>
-        <p:nvSpPr>
-          <p:cNvPr id="2" name="TextBox 1"/>
-          <p:cNvSpPr txBox="1"/>
-          <p:nvPr/>
-        </p:nvSpPr>
-        <p:spPr>
-          <a:xfrm>
-            <a:off x="457200" y="182880"/>
-            <a:ext cx="11274552" cy="914400"/>
-          </a:xfrm>
-          <a:prstGeom prst="rect">
-            <a:avLst/>
-          </a:prstGeom>
-          <a:noFill/>
-        </p:spPr>
-        <p:txBody>
-          <a:bodyPr wrap="none">
-            <a:spAutoFit/>
-          </a:bodyPr>
-          <a:lstStyle/>
-          <a:p>
-            <a:pPr algn="l"/>
-            <a:r>
-              <a:rPr sz="3500" b="1">
-                <a:solidFill>
-                  <a:srgbClr val="003865"/>
-                </a:solidFill>
-                <a:latin typeface="Century Gothic"/>
-              </a:rPr>
-              <a:t>Simulación: Dashboard de Alto Impacto (Knaflic)</a:t>
-            </a:r>
-          </a:p>
-        </p:txBody>
-      </p:sp>
-      <p:sp>
-        <p:nvSpPr>
-          <p:cNvPr id="3" name="Rectangle 2"/>
-          <p:cNvSpPr/>
-          <p:nvPr/>
-        </p:nvSpPr>
-        <p:spPr>
-          <a:xfrm>
-            <a:off x="457200" y="1097280"/>
-            <a:ext cx="11274552" cy="45720"/>
-          </a:xfrm>
-          <a:prstGeom prst="rect">
-            <a:avLst/>
-          </a:prstGeom>
-          <a:solidFill>
-            <a:srgbClr val="E85C0B"/>
-          </a:solidFill>
-          <a:ln>
-            <a:solidFill>
-              <a:srgbClr val="E85C0B"/>
-            </a:solidFill>
-          </a:ln>
-        </p:spPr>
-        <p:style>
-          <a:lnRef idx="1">
-            <a:schemeClr val="accent1"/>
-          </a:lnRef>
-          <a:fillRef idx="3">
-            <a:schemeClr val="accent1"/>
-          </a:fillRef>
-          <a:effectRef idx="2">
-            <a:schemeClr val="accent1"/>
-          </a:effectRef>
-          <a:fontRef idx="minor">
-            <a:schemeClr val="lt1"/>
-          </a:fontRef>
-        </p:style>
-        <p:txBody>
-          <a:bodyPr rtlCol="0" anchor="ctr"/>
-          <a:lstStyle/>
-          <a:p>
-            <a:pPr algn="ctr"/>
-          </a:p>
-        </p:txBody>
-      </p:sp>
-      <p:pic>
-        <p:nvPicPr>
-          <p:cNvPr id="4" name="Picture 3" descr="dashboard_mockup.png"/>
-          <p:cNvPicPr>
-            <a:picLocks noChangeAspect="1"/>
-          </p:cNvPicPr>
-          <p:nvPr/>
-        </p:nvPicPr>
-        <p:blipFill>
-          <a:blip r:embed="rId2"/>
-          <a:stretch>
-            <a:fillRect/>
-          </a:stretch>
-        </p:blipFill>
-        <p:spPr>
-          <a:xfrm>
-            <a:off x="1828800" y="1371600"/>
-            <a:ext cx="8503920" cy="8503920"/>
-          </a:xfrm>
-          <a:prstGeom prst="rect">
-            <a:avLst/>
-          </a:prstGeom>
-        </p:spPr>
-      </p:pic>
-    </p:spTree>
-  </p:cSld>
-  <p:clrMapOvr>
-    <a:masterClrMapping/>
-  </p:clrMapOvr>
-</p:sld>
-</file>
-
-<file path=ppt/slides/slide9.xml><?xml version="1.0" encoding="utf-8"?>
-<p:sld xmlns:a="http://schemas.openxmlformats.org/drawingml/2006/main" xmlns:p="http://schemas.openxmlformats.org/presentationml/2006/main" xmlns:r="http://schemas.openxmlformats.org/officeDocument/2006/relationships">
-  <p:cSld>
-    <p:bg>
-      <p:bgPr>
-        <a:solidFill>
-          <a:srgbClr val="F0F0F0"/>
-        </a:solidFill>
-        <a:effectLst/>
-      </p:bgPr>
-    </p:bg>
-    <p:spTree>
-      <p:nvGrpSpPr>
-        <p:cNvPr id="1" name=""/>
-        <p:cNvGrpSpPr/>
-        <p:nvPr/>
-      </p:nvGrpSpPr>
-      <p:grpSpPr/>
-      <p:sp>
-        <p:nvSpPr>
-          <p:cNvPr id="2" name="TextBox 1"/>
-          <p:cNvSpPr txBox="1"/>
-          <p:nvPr/>
-        </p:nvSpPr>
-        <p:spPr>
-          <a:xfrm>
-            <a:off x="457200" y="182880"/>
-            <a:ext cx="11274552" cy="914400"/>
-          </a:xfrm>
-          <a:prstGeom prst="rect">
-            <a:avLst/>
-          </a:prstGeom>
-          <a:noFill/>
-        </p:spPr>
-        <p:txBody>
-          <a:bodyPr wrap="none">
-            <a:spAutoFit/>
-          </a:bodyPr>
-          <a:lstStyle/>
-          <a:p>
-            <a:pPr algn="l"/>
-            <a:r>
-              <a:rPr sz="4000" b="1">
-                <a:solidFill>
-                  <a:srgbClr val="003865"/>
-                </a:solidFill>
-                <a:latin typeface="Century Gothic"/>
-              </a:rPr>
-              <a:t>Taller: Pair Programming</a:t>
-            </a:r>
-          </a:p>
-        </p:txBody>
-      </p:sp>
-      <p:sp>
-        <p:nvSpPr>
-          <p:cNvPr id="3" name="Rectangle 2"/>
-          <p:cNvSpPr/>
-          <p:nvPr/>
-        </p:nvSpPr>
-        <p:spPr>
-          <a:xfrm>
-            <a:off x="457200" y="1097280"/>
-            <a:ext cx="11274552" cy="45720"/>
-          </a:xfrm>
-          <a:prstGeom prst="rect">
-            <a:avLst/>
-          </a:prstGeom>
-          <a:solidFill>
-            <a:srgbClr val="E85C0B"/>
-          </a:solidFill>
-          <a:ln>
-            <a:solidFill>
-              <a:srgbClr val="E85C0B"/>
-            </a:solidFill>
-          </a:ln>
-        </p:spPr>
-        <p:style>
-          <a:lnRef idx="1">
-            <a:schemeClr val="accent1"/>
-          </a:lnRef>
-          <a:fillRef idx="3">
-            <a:schemeClr val="accent1"/>
-          </a:fillRef>
-          <a:effectRef idx="2">
-            <a:schemeClr val="accent1"/>
-          </a:effectRef>
-          <a:fontRef idx="minor">
-            <a:schemeClr val="lt1"/>
-          </a:fontRef>
-        </p:style>
-        <p:txBody>
-          <a:bodyPr rtlCol="0" anchor="ctr"/>
-          <a:lstStyle/>
-          <a:p>
-            <a:pPr algn="ctr"/>
-          </a:p>
-        </p:txBody>
-      </p:sp>
-      <p:sp>
-        <p:nvSpPr>
-          <p:cNvPr id="4" name="TextBox 3"/>
-          <p:cNvSpPr txBox="1"/>
-          <p:nvPr/>
-        </p:nvSpPr>
-        <p:spPr>
-          <a:xfrm>
-            <a:off x="457200" y="1280160"/>
-            <a:ext cx="11274552" cy="5303520"/>
-          </a:xfrm>
-          <a:prstGeom prst="rect">
-            <a:avLst/>
-          </a:prstGeom>
-          <a:noFill/>
-        </p:spPr>
-        <p:txBody>
-          <a:bodyPr wrap="square">
-            <a:spAutoFit/>
-          </a:bodyPr>
-          <a:lstStyle/>
-          <a:p/>
-          <a:p>
-            <a:pPr>
-              <a:spcAft>
-                <a:spcPts val="1000"/>
-              </a:spcAft>
-              <a:defRPr sz="3000" b="1">
-                <a:solidFill>
-                  <a:srgbClr val="E85C0B"/>
-                </a:solidFill>
-                <a:latin typeface="Century Gothic"/>
-              </a:defRPr>
-            </a:pPr>
-            <a:r>
-              <a:t>Análisis Crítico de Dashboards en el Mundo Real</a:t>
-            </a:r>
-          </a:p>
-          <a:p>
-            <a:pPr lvl="1">
-              <a:spcAft>
-                <a:spcPts val="1000"/>
-              </a:spcAft>
-              <a:defRPr sz="2400" b="0">
-                <a:solidFill>
-                  <a:srgbClr val="003865"/>
-                </a:solidFill>
-                <a:latin typeface="Century Gothic"/>
-              </a:defRPr>
-            </a:pPr>
-            <a:r>
-              <a:t>1. En parejas, busquen en internet 2 Dashboards (Uno saturado/malo y uno limpio/bueno).</a:t>
-            </a:r>
-          </a:p>
-          <a:p>
-            <a:pPr lvl="1">
-              <a:spcAft>
-                <a:spcPts val="1000"/>
-              </a:spcAft>
-              <a:defRPr sz="2400" b="0">
-                <a:solidFill>
-                  <a:srgbClr val="003865"/>
-                </a:solidFill>
-                <a:latin typeface="Century Gothic"/>
-              </a:defRPr>
-            </a:pPr>
-            <a:r>
-              <a:t>2. Analicen qué principios de Gestalt y 'Decluttering' se violan en el malo.</a:t>
-            </a:r>
-          </a:p>
-          <a:p>
-            <a:pPr lvl="1">
-              <a:spcAft>
-                <a:spcPts val="1000"/>
-              </a:spcAft>
-              <a:defRPr sz="2400" b="0">
-                <a:solidFill>
-                  <a:srgbClr val="003865"/>
-                </a:solidFill>
-                <a:latin typeface="Century Gothic"/>
-              </a:defRPr>
-            </a:pPr>
-            <a:r>
-              <a:t>3. Analicen la jerarquía visual del Dashboard bueno.</a:t>
-            </a:r>
-          </a:p>
-          <a:p>
-            <a:pPr lvl="1">
-              <a:spcAft>
-                <a:spcPts val="1000"/>
-              </a:spcAft>
-              <a:defRPr sz="2400" b="0">
-                <a:solidFill>
-                  <a:srgbClr val="003865"/>
-                </a:solidFill>
-                <a:latin typeface="Century Gothic"/>
-              </a:defRPr>
-            </a:pPr>
-            <a:r>
-              <a:t>4. Redacten un resumen en formato Markdown y súbanlo a su repositorio de GitHub.</a:t>
-            </a:r>
-          </a:p>
-          <a:p>
-            <a:pPr lvl="1">
-              <a:spcAft>
-                <a:spcPts val="1000"/>
-              </a:spcAft>
-              <a:defRPr sz="2400" b="1">
-                <a:solidFill>
-                  <a:srgbClr val="003865"/>
-                </a:solidFill>
-                <a:latin typeface="Century Gothic"/>
-              </a:defRPr>
-            </a:pPr>
-            <a:r>
-              <a:t>Nota: Usen LLMNotebook/ChatGPT como asistente crítico para la revisión.</a:t>
+              <a:t>Si un dashboard no puede leerse en 5 segundos, fracasó.</a:t>
             </a:r>
           </a:p>
         </p:txBody>

</xml_diff>